<commit_message>
Separate slide skills and restore full bibliography citations
</commit_message>
<xml_diff>
--- a/slides/datasets-in-10-minutes-imagenet.pptx
+++ b/slides/datasets-in-10-minutes-imagenet.pptx
@@ -69,9 +69,11 @@
     <p:sldId id="303" r:id="rId54"/>
     <p:sldId id="304" r:id="rId55"/>
     <p:sldId id="305" r:id="rId56"/>
-    <p:sldId id="306" r:id="rId57"/>
-    <p:sldId id="307" r:id="rId58"/>
-    <p:sldId id="322" r:id="rId72"/>
+    <p:sldId id="322" r:id="rId58"/>
+    <p:sldId id="323" r:id="rId57"/>
+    <p:sldId id="324" r:id="rId72"/>
+    <p:sldId id="325" r:id="rId73"/>
+    <p:sldId id="326" r:id="rId74"/>
   </p:sldIdLst>
   <p:sldSz cx="9144000" cy="5143500" type="screen16x9"/>
   <p:notesSz cx="6858000" cy="9144000"/>
@@ -44262,19 +44264,16 @@
             <p:ph type="title"/>
           </p:nvPr>
         </p:nvSpPr>
-        <p:spPr>
-          <a:xfrm>
-            <a:off x="468172" y="650138"/>
-            <a:ext cx="8206740" cy="616305"/>
-          </a:xfrm>
-        </p:spPr>
-        <p:txBody>
-          <a:bodyPr wrap="square" lIns="0" rIns="0" tIns="0" bIns="0" anchor="t"/>
+        <p:spPr/>
+        <p:txBody>
+          <a:bodyPr/>
           <a:lstStyle/>
           <a:p>
             <a:r>
-              <a:rPr sz="2800"/>
-              <a:t>読後の学習・研究に向けて</a:t>
+              <a:rPr sz="2800">
+                <a:latin typeface="Noto Sans"/>
+              </a:rPr>
+              <a:t>参考文献</a:t>
             </a:r>
           </a:p>
         </p:txBody>
@@ -44289,19 +44288,20 @@
             <p:ph type="title" idx="2"/>
           </p:nvPr>
         </p:nvSpPr>
-        <p:spPr>
-          <a:xfrm>
-            <a:off x="75895" y="0"/>
-            <a:ext cx="8115300" cy="480060"/>
-          </a:xfrm>
-        </p:spPr>
-        <p:txBody>
-          <a:bodyPr wrap="square" lIns="0" rIns="0" tIns="0" bIns="0" anchor="ctr"/>
+        <p:spPr/>
+        <p:txBody>
+          <a:bodyPr/>
           <a:lstStyle/>
           <a:p>
             <a:r>
-              <a:rPr sz="1400"/>
-              <a:t>Appendix: 7 参考文献・基礎を学ぶ</a:t>
+              <a:rPr sz="1400" b="1">
+                <a:solidFill>
+                  <a:srgbClr val="FFFEF8"/>
+                </a:solidFill>
+                <a:latin typeface="Noto Sans"/>
+                <a:ea typeface="Noto Sans CJK JP"/>
+              </a:rPr>
+              <a:t>Appendix: 7 参考文献</a:t>
             </a:r>
           </a:p>
         </p:txBody>
@@ -44314,8 +44314,8 @@
         </p:nvSpPr>
         <p:spPr>
           <a:xfrm>
-            <a:off x="594360" y="1353312"/>
-            <a:ext cx="7955279" cy="365760"/>
+            <a:off x="594360" y="1325058"/>
+            <a:ext cx="7955279" cy="455512"/>
           </a:xfrm>
           <a:prstGeom prst="rect">
             <a:avLst/>
@@ -44323,31 +44323,32 @@
           <a:noFill/>
         </p:spPr>
         <p:txBody>
-          <a:bodyPr wrap="square" lIns="0" rIns="0" tIns="0" bIns="0">
+          <a:bodyPr wrap="square" anchor="t" lIns="0" rIns="0" tIns="0" bIns="0">
             <a:spAutoFit/>
           </a:bodyPr>
           <a:lstStyle/>
           <a:p>
             <a:pPr>
               <a:lnSpc>
-                <a:spcPct val="108000"/>
-              </a:lnSpc>
-              <a:spcBef>
-                <a:spcPts val="0"/>
-              </a:spcBef>
-              <a:spcAft>
-                <a:spcPts val="0"/>
-              </a:spcAft>
-            </a:pPr>
-            <a:r>
-              <a:rPr sz="2100" b="1" lang="ja-JP">
+                <a:spcPct val="100000"/>
+              </a:lnSpc>
+              <a:spcBef>
+                <a:spcPts val="0"/>
+              </a:spcBef>
+              <a:spcAft>
+                <a:spcPts val="0"/>
+              </a:spcAft>
+              <a:buNone/>
+            </a:pPr>
+            <a:r>
+              <a:rPr sz="1900" b="1" lang="ja-JP">
                 <a:solidFill>
                   <a:srgbClr val="303437"/>
                 </a:solidFill>
                 <a:latin typeface="Noto Sans"/>
                 <a:ea typeface="Noto Sans CJK JP"/>
               </a:rPr>
-              <a:t>Deng et al. (2009). ImageNet. CVPR.</a:t>
+              <a:t>ImageNet: A Large-Scale Hierarchical Image Database</a:t>
             </a:r>
           </a:p>
         </p:txBody>
@@ -44360,8 +44361,8 @@
         </p:nvSpPr>
         <p:spPr>
           <a:xfrm>
-            <a:off x="594360" y="1746504"/>
-            <a:ext cx="7955279" cy="438912"/>
+            <a:off x="594360" y="1711857"/>
+            <a:ext cx="7955279" cy="360393"/>
           </a:xfrm>
           <a:prstGeom prst="rect">
             <a:avLst/>
@@ -44369,31 +44370,32 @@
           <a:noFill/>
         </p:spPr>
         <p:txBody>
-          <a:bodyPr wrap="square" lIns="0" rIns="0" tIns="0" bIns="0">
+          <a:bodyPr wrap="square" anchor="t" lIns="0" rIns="0" tIns="0" bIns="0">
             <a:spAutoFit/>
           </a:bodyPr>
           <a:lstStyle/>
           <a:p>
             <a:pPr>
               <a:lnSpc>
-                <a:spcPct val="108000"/>
-              </a:lnSpc>
-              <a:spcBef>
-                <a:spcPts val="0"/>
-              </a:spcBef>
-              <a:spcAft>
-                <a:spcPts val="0"/>
-              </a:spcAft>
-            </a:pPr>
-            <a:r>
-              <a:rPr sz="2000" b="0" lang="ja-JP">
+                <a:spcPct val="100000"/>
+              </a:lnSpc>
+              <a:spcBef>
+                <a:spcPts val="0"/>
+              </a:spcBef>
+              <a:spcAft>
+                <a:spcPts val="0"/>
+              </a:spcAft>
+              <a:buNone/>
+            </a:pPr>
+            <a:r>
+              <a:rPr sz="1350" b="0" lang="ja-JP">
                 <a:solidFill>
                   <a:srgbClr val="303437"/>
                 </a:solidFill>
                 <a:latin typeface="Noto Sans"/>
                 <a:ea typeface="Noto Sans CJK JP"/>
               </a:rPr>
-              <a:t>まず、画像の収集・注釈とWordNetによる階層設計を学ぶ。</a:t>
+              <a:t>Deng, J., Dong, W., Socher, R., Li, L.-J., Li, K., &amp; Fei-Fei, L. (2009). CVPR, pp. 248–255.</a:t>
             </a:r>
           </a:p>
         </p:txBody>
@@ -44406,8 +44408,8 @@
         </p:nvSpPr>
         <p:spPr>
           <a:xfrm>
-            <a:off x="594360" y="2221991"/>
-            <a:ext cx="7955279" cy="228600"/>
+            <a:off x="594360" y="2059475"/>
+            <a:ext cx="7955279" cy="732332"/>
           </a:xfrm>
           <a:prstGeom prst="rect">
             <a:avLst/>
@@ -44415,32 +44417,32 @@
           <a:noFill/>
         </p:spPr>
         <p:txBody>
-          <a:bodyPr wrap="square" lIns="0" rIns="0" tIns="0" bIns="0">
+          <a:bodyPr wrap="square" anchor="t" lIns="0" rIns="0" tIns="0" bIns="0">
             <a:spAutoFit/>
           </a:bodyPr>
           <a:lstStyle/>
           <a:p>
             <a:pPr>
               <a:lnSpc>
-                <a:spcPct val="108000"/>
-              </a:lnSpc>
-              <a:spcBef>
-                <a:spcPts val="0"/>
-              </a:spcBef>
-              <a:spcAft>
-                <a:spcPts val="0"/>
-              </a:spcAft>
-            </a:pPr>
-            <a:r>
-              <a:rPr sz="1050" b="0" lang="ja-JP">
-                <a:solidFill>
-                  <a:srgbClr val="626669"/>
-                </a:solidFill>
-                <a:latin typeface="Noto Sans"/>
-                <a:ea typeface="Noto Sans CJK JP"/>
-                <a:hlinkClick r:id="rId2"/>
-              </a:rPr>
-              <a:t>https://image-net.org/static_files/papers/imagenet_cvpr09.pdf</a:t>
+                <a:spcPct val="100000"/>
+              </a:lnSpc>
+              <a:spcBef>
+                <a:spcPts val="0"/>
+              </a:spcBef>
+              <a:spcAft>
+                <a:spcPts val="0"/>
+              </a:spcAft>
+              <a:buNone/>
+            </a:pPr>
+            <a:r>
+              <a:rPr sz="1800" b="0" lang="ja-JP">
+                <a:solidFill>
+                  <a:srgbClr val="303437"/>
+                </a:solidFill>
+                <a:latin typeface="Noto Sans"/>
+                <a:ea typeface="Noto Sans CJK JP"/>
+              </a:rPr>
+              <a:t>ImageNetの原著論文。WordNet階層に沿う画像収集と人手による注釈を報告する。</a:t>
             </a:r>
           </a:p>
         </p:txBody>
@@ -44453,8 +44455,8 @@
         </p:nvSpPr>
         <p:spPr>
           <a:xfrm>
-            <a:off x="594360" y="2487168"/>
-            <a:ext cx="7955279" cy="365760"/>
+            <a:off x="594360" y="2700922"/>
+            <a:ext cx="7955279" cy="308415"/>
           </a:xfrm>
           <a:prstGeom prst="rect">
             <a:avLst/>
@@ -44462,31 +44464,33 @@
           <a:noFill/>
         </p:spPr>
         <p:txBody>
-          <a:bodyPr wrap="square" lIns="0" rIns="0" tIns="0" bIns="0">
+          <a:bodyPr wrap="square" anchor="t" lIns="0" rIns="0" tIns="0" bIns="0">
             <a:spAutoFit/>
           </a:bodyPr>
           <a:lstStyle/>
           <a:p>
             <a:pPr>
               <a:lnSpc>
-                <a:spcPct val="108000"/>
-              </a:lnSpc>
-              <a:spcBef>
-                <a:spcPts val="0"/>
-              </a:spcBef>
-              <a:spcAft>
-                <a:spcPts val="0"/>
-              </a:spcAft>
-            </a:pPr>
-            <a:r>
-              <a:rPr sz="2100" b="1" lang="ja-JP">
-                <a:solidFill>
-                  <a:srgbClr val="303437"/>
-                </a:solidFill>
-                <a:latin typeface="Noto Sans"/>
-                <a:ea typeface="Noto Sans CJK JP"/>
-              </a:rPr>
-              <a:t>Russakovsky et al. (2015). ILSVRC. IJCV.</a:t>
+                <a:spcPct val="100000"/>
+              </a:lnSpc>
+              <a:spcBef>
+                <a:spcPts val="0"/>
+              </a:spcBef>
+              <a:spcAft>
+                <a:spcPts val="0"/>
+              </a:spcAft>
+              <a:buNone/>
+            </a:pPr>
+            <a:r>
+              <a:rPr sz="1050" b="0" lang="ja-JP">
+                <a:solidFill>
+                  <a:srgbClr val="626669"/>
+                </a:solidFill>
+                <a:latin typeface="Noto Sans"/>
+                <a:ea typeface="Noto Sans CJK JP"/>
+                <a:hlinkClick r:id="rId2"/>
+              </a:rPr>
+              <a:t>https://image-net.org/static_files/papers/imagenet_cvpr09.pdf</a:t>
             </a:r>
           </a:p>
         </p:txBody>
@@ -44499,8 +44503,8 @@
         </p:nvSpPr>
         <p:spPr>
           <a:xfrm>
-            <a:off x="594360" y="2880360"/>
-            <a:ext cx="7955279" cy="438912"/>
+            <a:off x="594360" y="3118211"/>
+            <a:ext cx="7955279" cy="455512"/>
           </a:xfrm>
           <a:prstGeom prst="rect">
             <a:avLst/>
@@ -44508,31 +44512,32 @@
           <a:noFill/>
         </p:spPr>
         <p:txBody>
-          <a:bodyPr wrap="square" lIns="0" rIns="0" tIns="0" bIns="0">
+          <a:bodyPr wrap="square" anchor="t" lIns="0" rIns="0" tIns="0" bIns="0">
             <a:spAutoFit/>
           </a:bodyPr>
           <a:lstStyle/>
           <a:p>
             <a:pPr>
               <a:lnSpc>
-                <a:spcPct val="108000"/>
-              </a:lnSpc>
-              <a:spcBef>
-                <a:spcPts val="0"/>
-              </a:spcBef>
-              <a:spcAft>
-                <a:spcPts val="0"/>
-              </a:spcAft>
-            </a:pPr>
-            <a:r>
-              <a:rPr sz="2000" b="0" lang="ja-JP">
+                <a:spcPct val="100000"/>
+              </a:lnSpc>
+              <a:spcBef>
+                <a:spcPts val="0"/>
+              </a:spcBef>
+              <a:spcAft>
+                <a:spcPts val="0"/>
+              </a:spcAft>
+              <a:buNone/>
+            </a:pPr>
+            <a:r>
+              <a:rPr sz="1900" b="1" lang="ja-JP">
                 <a:solidFill>
                   <a:srgbClr val="303437"/>
                 </a:solidFill>
                 <a:latin typeface="Noto Sans"/>
                 <a:ea typeface="Noto Sans CJK JP"/>
               </a:rPr>
-              <a:t>分類・検出・位置推定の課題と、評価手順の違いを整理する。</a:t>
+              <a:t>ImageNet Large Scale Visual Recognition Challenge</a:t>
             </a:r>
           </a:p>
         </p:txBody>
@@ -44545,8 +44550,8 @@
         </p:nvSpPr>
         <p:spPr>
           <a:xfrm>
-            <a:off x="594360" y="3355848"/>
-            <a:ext cx="7955279" cy="228600"/>
+            <a:off x="594360" y="3505011"/>
+            <a:ext cx="7955279" cy="360393"/>
           </a:xfrm>
           <a:prstGeom prst="rect">
             <a:avLst/>
@@ -44554,32 +44559,32 @@
           <a:noFill/>
         </p:spPr>
         <p:txBody>
-          <a:bodyPr wrap="square" lIns="0" rIns="0" tIns="0" bIns="0">
+          <a:bodyPr wrap="square" anchor="t" lIns="0" rIns="0" tIns="0" bIns="0">
             <a:spAutoFit/>
           </a:bodyPr>
           <a:lstStyle/>
           <a:p>
             <a:pPr>
               <a:lnSpc>
-                <a:spcPct val="108000"/>
-              </a:lnSpc>
-              <a:spcBef>
-                <a:spcPts val="0"/>
-              </a:spcBef>
-              <a:spcAft>
-                <a:spcPts val="0"/>
-              </a:spcAft>
-            </a:pPr>
-            <a:r>
-              <a:rPr sz="1050" b="0" lang="ja-JP">
-                <a:solidFill>
-                  <a:srgbClr val="626669"/>
-                </a:solidFill>
-                <a:latin typeface="Noto Sans"/>
-                <a:ea typeface="Noto Sans CJK JP"/>
-                <a:hlinkClick r:id="rId3"/>
-              </a:rPr>
-              <a:t>https://arxiv.org/abs/1409.0575</a:t>
+                <a:spcPct val="100000"/>
+              </a:lnSpc>
+              <a:spcBef>
+                <a:spcPts val="0"/>
+              </a:spcBef>
+              <a:spcAft>
+                <a:spcPts val="0"/>
+              </a:spcAft>
+              <a:buNone/>
+            </a:pPr>
+            <a:r>
+              <a:rPr sz="1350" b="0" lang="ja-JP">
+                <a:solidFill>
+                  <a:srgbClr val="303437"/>
+                </a:solidFill>
+                <a:latin typeface="Noto Sans"/>
+                <a:ea typeface="Noto Sans CJK JP"/>
+              </a:rPr>
+              <a:t>Russakovsky, O., et al. (2015). International Journal of Computer Vision, 115, pp. 211–252.</a:t>
             </a:r>
           </a:p>
         </p:txBody>
@@ -44592,8 +44597,8 @@
         </p:nvSpPr>
         <p:spPr>
           <a:xfrm>
-            <a:off x="594360" y="3621024"/>
-            <a:ext cx="7955279" cy="365760"/>
+            <a:off x="594360" y="3852629"/>
+            <a:ext cx="7955279" cy="732332"/>
           </a:xfrm>
           <a:prstGeom prst="rect">
             <a:avLst/>
@@ -44601,31 +44606,32 @@
           <a:noFill/>
         </p:spPr>
         <p:txBody>
-          <a:bodyPr wrap="square" lIns="0" rIns="0" tIns="0" bIns="0">
+          <a:bodyPr wrap="square" anchor="t" lIns="0" rIns="0" tIns="0" bIns="0">
             <a:spAutoFit/>
           </a:bodyPr>
           <a:lstStyle/>
           <a:p>
             <a:pPr>
               <a:lnSpc>
-                <a:spcPct val="108000"/>
-              </a:lnSpc>
-              <a:spcBef>
-                <a:spcPts val="0"/>
-              </a:spcBef>
-              <a:spcAft>
-                <a:spcPts val="0"/>
-              </a:spcAft>
-            </a:pPr>
-            <a:r>
-              <a:rPr sz="2100" b="1" lang="ja-JP">
+                <a:spcPct val="100000"/>
+              </a:lnSpc>
+              <a:spcBef>
+                <a:spcPts val="0"/>
+              </a:spcBef>
+              <a:spcAft>
+                <a:spcPts val="0"/>
+              </a:spcAft>
+              <a:buNone/>
+            </a:pPr>
+            <a:r>
+              <a:rPr sz="1800" b="0" lang="ja-JP">
                 <a:solidFill>
                   <a:srgbClr val="303437"/>
                 </a:solidFill>
                 <a:latin typeface="Noto Sans"/>
                 <a:ea typeface="Noto Sans CJK JP"/>
               </a:rPr>
-              <a:t>He et al. (2016). Deep Residual Learning. CVPR.</a:t>
+              <a:t>ILSVRCの総括論文。画像分類・検出・位置推定の課題と評価結果をまとめている。</a:t>
             </a:r>
           </a:p>
         </p:txBody>
@@ -44638,8 +44644,8 @@
         </p:nvSpPr>
         <p:spPr>
           <a:xfrm>
-            <a:off x="594360" y="4014215"/>
-            <a:ext cx="7955279" cy="438912"/>
+            <a:off x="594360" y="4494076"/>
+            <a:ext cx="7955279" cy="308415"/>
           </a:xfrm>
           <a:prstGeom prst="rect">
             <a:avLst/>
@@ -44647,67 +44653,22 @@
           <a:noFill/>
         </p:spPr>
         <p:txBody>
-          <a:bodyPr wrap="square" lIns="0" rIns="0" tIns="0" bIns="0">
+          <a:bodyPr wrap="square" anchor="t" lIns="0" rIns="0" tIns="0" bIns="0">
             <a:spAutoFit/>
           </a:bodyPr>
           <a:lstStyle/>
           <a:p>
             <a:pPr>
               <a:lnSpc>
-                <a:spcPct val="108000"/>
-              </a:lnSpc>
-              <a:spcBef>
-                <a:spcPts val="0"/>
-              </a:spcBef>
-              <a:spcAft>
-                <a:spcPts val="0"/>
-              </a:spcAft>
-            </a:pPr>
-            <a:r>
-              <a:rPr sz="2000" b="0" lang="ja-JP">
-                <a:solidFill>
-                  <a:srgbClr val="303437"/>
-                </a:solidFill>
-                <a:latin typeface="Noto Sans"/>
-                <a:ea typeface="Noto Sans CJK JP"/>
-              </a:rPr>
-              <a:t>残差接続が深い画像認識モデルの学習をどう支えるかを読む。</a:t>
-            </a:r>
-          </a:p>
-        </p:txBody>
-      </p:sp>
-      <p:sp>
-        <p:nvSpPr>
-          <p:cNvPr id="12" name="TextBox 11"/>
-          <p:cNvSpPr txBox="1"/>
-          <p:nvPr/>
-        </p:nvSpPr>
-        <p:spPr>
-          <a:xfrm>
-            <a:off x="594360" y="4489704"/>
-            <a:ext cx="7955279" cy="228600"/>
-          </a:xfrm>
-          <a:prstGeom prst="rect">
-            <a:avLst/>
-          </a:prstGeom>
-          <a:noFill/>
-        </p:spPr>
-        <p:txBody>
-          <a:bodyPr wrap="square" lIns="0" rIns="0" tIns="0" bIns="0">
-            <a:spAutoFit/>
-          </a:bodyPr>
-          <a:lstStyle/>
-          <a:p>
-            <a:pPr>
-              <a:lnSpc>
-                <a:spcPct val="108000"/>
-              </a:lnSpc>
-              <a:spcBef>
-                <a:spcPts val="0"/>
-              </a:spcBef>
-              <a:spcAft>
-                <a:spcPts val="0"/>
-              </a:spcAft>
+                <a:spcPct val="100000"/>
+              </a:lnSpc>
+              <a:spcBef>
+                <a:spcPts val="0"/>
+              </a:spcBef>
+              <a:spcAft>
+                <a:spcPts val="0"/>
+              </a:spcAft>
+              <a:buNone/>
             </a:pPr>
             <a:r>
               <a:rPr sz="1050" b="0" lang="ja-JP">
@@ -44716,9 +44677,9 @@
                 </a:solidFill>
                 <a:latin typeface="Noto Sans"/>
                 <a:ea typeface="Noto Sans CJK JP"/>
-                <a:hlinkClick r:id="rId4"/>
-              </a:rPr>
-              <a:t>https://arxiv.org/abs/1512.03385</a:t>
+                <a:hlinkClick r:id="rId3"/>
+              </a:rPr>
+              <a:t>https://arxiv.org/abs/1409.0575</a:t>
             </a:r>
           </a:p>
         </p:txBody>
@@ -44751,19 +44712,16 @@
             <p:ph type="title"/>
           </p:nvPr>
         </p:nvSpPr>
-        <p:spPr>
-          <a:xfrm>
-            <a:off x="468172" y="650138"/>
-            <a:ext cx="8206740" cy="616305"/>
-          </a:xfrm>
-        </p:spPr>
-        <p:txBody>
-          <a:bodyPr wrap="square" lIns="0" rIns="0" tIns="0" bIns="0" anchor="t"/>
+        <p:spPr/>
+        <p:txBody>
+          <a:bodyPr/>
           <a:lstStyle/>
           <a:p>
             <a:r>
-              <a:rPr sz="2800"/>
-              <a:t>読後の学習・研究に向けて</a:t>
+              <a:rPr sz="2800">
+                <a:latin typeface="Noto Sans"/>
+              </a:rPr>
+              <a:t>参考文献</a:t>
             </a:r>
           </a:p>
         </p:txBody>
@@ -44778,19 +44736,20 @@
             <p:ph type="title" idx="2"/>
           </p:nvPr>
         </p:nvSpPr>
-        <p:spPr>
-          <a:xfrm>
-            <a:off x="75895" y="0"/>
-            <a:ext cx="8115300" cy="480060"/>
-          </a:xfrm>
-        </p:spPr>
-        <p:txBody>
-          <a:bodyPr wrap="square" lIns="0" rIns="0" tIns="0" bIns="0" anchor="ctr"/>
+        <p:spPr/>
+        <p:txBody>
+          <a:bodyPr/>
           <a:lstStyle/>
           <a:p>
             <a:r>
-              <a:rPr sz="1400"/>
-              <a:t>Appendix: 7 参考文献・実装を試す</a:t>
+              <a:rPr sz="1400" b="1">
+                <a:solidFill>
+                  <a:srgbClr val="FFFEF8"/>
+                </a:solidFill>
+                <a:latin typeface="Noto Sans"/>
+                <a:ea typeface="Noto Sans CJK JP"/>
+              </a:rPr>
+              <a:t>Appendix: 7 参考文献</a:t>
             </a:r>
           </a:p>
         </p:txBody>
@@ -44803,8 +44762,8 @@
         </p:nvSpPr>
         <p:spPr>
           <a:xfrm>
-            <a:off x="594360" y="1353312"/>
-            <a:ext cx="7955279" cy="365760"/>
+            <a:off x="594360" y="1325058"/>
+            <a:ext cx="7955279" cy="455512"/>
           </a:xfrm>
           <a:prstGeom prst="rect">
             <a:avLst/>
@@ -44812,31 +44771,32 @@
           <a:noFill/>
         </p:spPr>
         <p:txBody>
-          <a:bodyPr wrap="square" lIns="0" rIns="0" tIns="0" bIns="0">
+          <a:bodyPr wrap="square" anchor="t" lIns="0" rIns="0" tIns="0" bIns="0">
             <a:spAutoFit/>
           </a:bodyPr>
           <a:lstStyle/>
           <a:p>
             <a:pPr>
               <a:lnSpc>
-                <a:spcPct val="108000"/>
-              </a:lnSpc>
-              <a:spcBef>
-                <a:spcPts val="0"/>
-              </a:spcBef>
-              <a:spcAft>
-                <a:spcPts val="0"/>
-              </a:spcAft>
-            </a:pPr>
-            <a:r>
-              <a:rPr sz="2100" b="1" lang="ja-JP">
+                <a:spcPct val="100000"/>
+              </a:lnSpc>
+              <a:spcBef>
+                <a:spcPts val="0"/>
+              </a:spcBef>
+              <a:spcAft>
+                <a:spcPts val="0"/>
+              </a:spcAft>
+              <a:buNone/>
+            </a:pPr>
+            <a:r>
+              <a:rPr sz="1900" b="1" lang="ja-JP">
                 <a:solidFill>
                   <a:srgbClr val="303437"/>
                 </a:solidFill>
                 <a:latin typeface="Noto Sans"/>
                 <a:ea typeface="Noto Sans CJK JP"/>
               </a:rPr>
-              <a:t>PyTorch公式・転移学習チュートリアル</a:t>
+              <a:t>Deep Residual Learning for Image Recognition</a:t>
             </a:r>
           </a:p>
         </p:txBody>
@@ -44849,8 +44809,8 @@
         </p:nvSpPr>
         <p:spPr>
           <a:xfrm>
-            <a:off x="594360" y="1746504"/>
-            <a:ext cx="7955279" cy="438912"/>
+            <a:off x="594360" y="1711857"/>
+            <a:ext cx="7955279" cy="360393"/>
           </a:xfrm>
           <a:prstGeom prst="rect">
             <a:avLst/>
@@ -44858,31 +44818,32 @@
           <a:noFill/>
         </p:spPr>
         <p:txBody>
-          <a:bodyPr wrap="square" lIns="0" rIns="0" tIns="0" bIns="0">
+          <a:bodyPr wrap="square" anchor="t" lIns="0" rIns="0" tIns="0" bIns="0">
             <a:spAutoFit/>
           </a:bodyPr>
           <a:lstStyle/>
           <a:p>
             <a:pPr>
               <a:lnSpc>
-                <a:spcPct val="108000"/>
-              </a:lnSpc>
-              <a:spcBef>
-                <a:spcPts val="0"/>
-              </a:spcBef>
-              <a:spcAft>
-                <a:spcPts val="0"/>
-              </a:spcAft>
-            </a:pPr>
-            <a:r>
-              <a:rPr sz="2000" b="0" lang="ja-JP">
+                <a:spcPct val="100000"/>
+              </a:lnSpc>
+              <a:spcBef>
+                <a:spcPts val="0"/>
+              </a:spcBef>
+              <a:spcAft>
+                <a:spcPts val="0"/>
+              </a:spcAft>
+              <a:buNone/>
+            </a:pPr>
+            <a:r>
+              <a:rPr sz="1350" b="0" lang="ja-JP">
                 <a:solidFill>
                   <a:srgbClr val="303437"/>
                 </a:solidFill>
                 <a:latin typeface="Noto Sans"/>
                 <a:ea typeface="Noto Sans CJK JP"/>
               </a:rPr>
-              <a:t>事前学習済みモデルを使い、微調整と特徴抽出を実装する。</a:t>
+              <a:t>He, K., Zhang, X., Ren, S., &amp; Sun, J. (2016). CVPR, pp. 770–778.</a:t>
             </a:r>
           </a:p>
         </p:txBody>
@@ -44895,8 +44856,8 @@
         </p:nvSpPr>
         <p:spPr>
           <a:xfrm>
-            <a:off x="594360" y="2221991"/>
-            <a:ext cx="7955279" cy="228600"/>
+            <a:off x="594360" y="2059475"/>
+            <a:ext cx="7955279" cy="732332"/>
           </a:xfrm>
           <a:prstGeom prst="rect">
             <a:avLst/>
@@ -44904,32 +44865,32 @@
           <a:noFill/>
         </p:spPr>
         <p:txBody>
-          <a:bodyPr wrap="square" lIns="0" rIns="0" tIns="0" bIns="0">
+          <a:bodyPr wrap="square" anchor="t" lIns="0" rIns="0" tIns="0" bIns="0">
             <a:spAutoFit/>
           </a:bodyPr>
           <a:lstStyle/>
           <a:p>
             <a:pPr>
               <a:lnSpc>
-                <a:spcPct val="108000"/>
-              </a:lnSpc>
-              <a:spcBef>
-                <a:spcPts val="0"/>
-              </a:spcBef>
-              <a:spcAft>
-                <a:spcPts val="0"/>
-              </a:spcAft>
-            </a:pPr>
-            <a:r>
-              <a:rPr sz="1050" b="0" lang="ja-JP">
-                <a:solidFill>
-                  <a:srgbClr val="626669"/>
-                </a:solidFill>
-                <a:latin typeface="Noto Sans"/>
-                <a:ea typeface="Noto Sans CJK JP"/>
-                <a:hlinkClick r:id="rId2"/>
-              </a:rPr>
-              <a:t>https://github.com/pytorch/tutorials/blob/main/beginner_source/transfer_learning_tutorial.py</a:t>
+                <a:spcPct val="100000"/>
+              </a:lnSpc>
+              <a:spcBef>
+                <a:spcPts val="0"/>
+              </a:spcBef>
+              <a:spcAft>
+                <a:spcPts val="0"/>
+              </a:spcAft>
+              <a:buNone/>
+            </a:pPr>
+            <a:r>
+              <a:rPr sz="1800" b="0" lang="ja-JP">
+                <a:solidFill>
+                  <a:srgbClr val="303437"/>
+                </a:solidFill>
+                <a:latin typeface="Noto Sans"/>
+                <a:ea typeface="Noto Sans CJK JP"/>
+              </a:rPr>
+              <a:t>ResNetの原著論文。残差接続による深いネットワークの学習とImageNet評価を示す。</a:t>
             </a:r>
           </a:p>
         </p:txBody>
@@ -44942,8 +44903,8 @@
         </p:nvSpPr>
         <p:spPr>
           <a:xfrm>
-            <a:off x="594360" y="2487168"/>
-            <a:ext cx="7955279" cy="365760"/>
+            <a:off x="594360" y="2700922"/>
+            <a:ext cx="7955279" cy="308415"/>
           </a:xfrm>
           <a:prstGeom prst="rect">
             <a:avLst/>
@@ -44951,31 +44912,33 @@
           <a:noFill/>
         </p:spPr>
         <p:txBody>
-          <a:bodyPr wrap="square" lIns="0" rIns="0" tIns="0" bIns="0">
+          <a:bodyPr wrap="square" anchor="t" lIns="0" rIns="0" tIns="0" bIns="0">
             <a:spAutoFit/>
           </a:bodyPr>
           <a:lstStyle/>
           <a:p>
             <a:pPr>
               <a:lnSpc>
-                <a:spcPct val="108000"/>
-              </a:lnSpc>
-              <a:spcBef>
-                <a:spcPts val="0"/>
-              </a:spcBef>
-              <a:spcAft>
-                <a:spcPts val="0"/>
-              </a:spcAft>
-            </a:pPr>
-            <a:r>
-              <a:rPr sz="2100" b="1" lang="ja-JP">
-                <a:solidFill>
-                  <a:srgbClr val="303437"/>
-                </a:solidFill>
-                <a:latin typeface="Noto Sans"/>
-                <a:ea typeface="Noto Sans CJK JP"/>
-              </a:rPr>
-              <a:t>Torchvision公式・モデルと学習済み重み</a:t>
+                <a:spcPct val="100000"/>
+              </a:lnSpc>
+              <a:spcBef>
+                <a:spcPts val="0"/>
+              </a:spcBef>
+              <a:spcAft>
+                <a:spcPts val="0"/>
+              </a:spcAft>
+              <a:buNone/>
+            </a:pPr>
+            <a:r>
+              <a:rPr sz="1050" b="0" lang="ja-JP">
+                <a:solidFill>
+                  <a:srgbClr val="626669"/>
+                </a:solidFill>
+                <a:latin typeface="Noto Sans"/>
+                <a:ea typeface="Noto Sans CJK JP"/>
+                <a:hlinkClick r:id="rId2"/>
+              </a:rPr>
+              <a:t>https://arxiv.org/abs/1512.03385</a:t>
             </a:r>
           </a:p>
         </p:txBody>
@@ -44988,8 +44951,8 @@
         </p:nvSpPr>
         <p:spPr>
           <a:xfrm>
-            <a:off x="594360" y="2880360"/>
-            <a:ext cx="7955279" cy="438912"/>
+            <a:off x="594360" y="3118211"/>
+            <a:ext cx="7955279" cy="455512"/>
           </a:xfrm>
           <a:prstGeom prst="rect">
             <a:avLst/>
@@ -44997,31 +44960,32 @@
           <a:noFill/>
         </p:spPr>
         <p:txBody>
-          <a:bodyPr wrap="square" lIns="0" rIns="0" tIns="0" bIns="0">
+          <a:bodyPr wrap="square" anchor="t" lIns="0" rIns="0" tIns="0" bIns="0">
             <a:spAutoFit/>
           </a:bodyPr>
           <a:lstStyle/>
           <a:p>
             <a:pPr>
               <a:lnSpc>
-                <a:spcPct val="108000"/>
-              </a:lnSpc>
-              <a:spcBef>
-                <a:spcPts val="0"/>
-              </a:spcBef>
-              <a:spcAft>
-                <a:spcPts val="0"/>
-              </a:spcAft>
-            </a:pPr>
-            <a:r>
-              <a:rPr sz="2000" b="0" lang="ja-JP">
+                <a:spcPct val="100000"/>
+              </a:lnSpc>
+              <a:spcBef>
+                <a:spcPts val="0"/>
+              </a:spcBef>
+              <a:spcAft>
+                <a:spcPts val="0"/>
+              </a:spcAft>
+              <a:buNone/>
+            </a:pPr>
+            <a:r>
+              <a:rPr sz="1900" b="1" lang="ja-JP">
                 <a:solidFill>
                   <a:srgbClr val="303437"/>
                 </a:solidFill>
                 <a:latin typeface="Noto Sans"/>
                 <a:ea typeface="Noto Sans CJK JP"/>
               </a:rPr>
-              <a:t>重みごとの前処理・クラス定義を確認し、推論を再現する。</a:t>
+              <a:t>Transfer Learning for Computer Vision Tutorial</a:t>
             </a:r>
           </a:p>
         </p:txBody>
@@ -45034,8 +44998,8 @@
         </p:nvSpPr>
         <p:spPr>
           <a:xfrm>
-            <a:off x="594360" y="3355848"/>
-            <a:ext cx="7955279" cy="228600"/>
+            <a:off x="594360" y="3520605"/>
+            <a:ext cx="7955279" cy="375987"/>
           </a:xfrm>
           <a:prstGeom prst="rect">
             <a:avLst/>
@@ -45043,32 +45007,32 @@
           <a:noFill/>
         </p:spPr>
         <p:txBody>
-          <a:bodyPr wrap="square" lIns="0" rIns="0" tIns="0" bIns="0">
+          <a:bodyPr wrap="square" anchor="t" lIns="0" rIns="0" tIns="0" bIns="0">
             <a:spAutoFit/>
           </a:bodyPr>
           <a:lstStyle/>
           <a:p>
             <a:pPr>
               <a:lnSpc>
-                <a:spcPct val="108000"/>
-              </a:lnSpc>
-              <a:spcBef>
-                <a:spcPts val="0"/>
-              </a:spcBef>
-              <a:spcAft>
-                <a:spcPts val="0"/>
-              </a:spcAft>
-            </a:pPr>
-            <a:r>
-              <a:rPr sz="1050" b="0" lang="ja-JP">
-                <a:solidFill>
-                  <a:srgbClr val="626669"/>
-                </a:solidFill>
-                <a:latin typeface="Noto Sans"/>
-                <a:ea typeface="Noto Sans CJK JP"/>
-                <a:hlinkClick r:id="rId3"/>
-              </a:rPr>
-              <a:t>https://github.com/pytorch/vision/tree/main/docs/source/models</a:t>
+                <a:spcPct val="100000"/>
+              </a:lnSpc>
+              <a:spcBef>
+                <a:spcPts val="0"/>
+              </a:spcBef>
+              <a:spcAft>
+                <a:spcPts val="0"/>
+              </a:spcAft>
+              <a:buNone/>
+            </a:pPr>
+            <a:r>
+              <a:rPr sz="1350" b="0" lang="ja-JP">
+                <a:solidFill>
+                  <a:srgbClr val="303437"/>
+                </a:solidFill>
+                <a:latin typeface="Noto Sans"/>
+                <a:ea typeface="Noto Sans CJK JP"/>
+              </a:rPr>
+              <a:t>Chilamkurthy, S. (n.d.). PyTorch Tutorials. 参照 2026-10-15.</a:t>
             </a:r>
           </a:p>
         </p:txBody>
@@ -45081,8 +45045,8 @@
         </p:nvSpPr>
         <p:spPr>
           <a:xfrm>
-            <a:off x="594360" y="3621024"/>
-            <a:ext cx="7955279" cy="365760"/>
+            <a:off x="594360" y="3868223"/>
+            <a:ext cx="7955279" cy="732332"/>
           </a:xfrm>
           <a:prstGeom prst="rect">
             <a:avLst/>
@@ -45090,31 +45054,32 @@
           <a:noFill/>
         </p:spPr>
         <p:txBody>
-          <a:bodyPr wrap="square" lIns="0" rIns="0" tIns="0" bIns="0">
+          <a:bodyPr wrap="square" anchor="t" lIns="0" rIns="0" tIns="0" bIns="0">
             <a:spAutoFit/>
           </a:bodyPr>
           <a:lstStyle/>
           <a:p>
             <a:pPr>
               <a:lnSpc>
-                <a:spcPct val="108000"/>
-              </a:lnSpc>
-              <a:spcBef>
-                <a:spcPts val="0"/>
-              </a:spcBef>
-              <a:spcAft>
-                <a:spcPts val="0"/>
-              </a:spcAft>
-            </a:pPr>
-            <a:r>
-              <a:rPr sz="2100" b="1" lang="ja-JP">
+                <a:spcPct val="100000"/>
+              </a:lnSpc>
+              <a:spcBef>
+                <a:spcPts val="0"/>
+              </a:spcBef>
+              <a:spcAft>
+                <a:spcPts val="0"/>
+              </a:spcAft>
+              <a:buNone/>
+            </a:pPr>
+            <a:r>
+              <a:rPr sz="1800" b="0" lang="ja-JP">
                 <a:solidFill>
                   <a:srgbClr val="303437"/>
                 </a:solidFill>
                 <a:latin typeface="Noto Sans"/>
                 <a:ea typeface="Noto Sans CJK JP"/>
               </a:rPr>
-              <a:t>fastai. Imagenette.</a:t>
+              <a:t>PyTorchの公式教材。事前学習済みモデルの微調整と固定特徴による分類を実装している。</a:t>
             </a:r>
           </a:p>
         </p:txBody>
@@ -45127,8 +45092,8 @@
         </p:nvSpPr>
         <p:spPr>
           <a:xfrm>
-            <a:off x="594360" y="4014215"/>
-            <a:ext cx="7955279" cy="438912"/>
+            <a:off x="594360" y="4509670"/>
+            <a:ext cx="7955279" cy="308415"/>
           </a:xfrm>
           <a:prstGeom prst="rect">
             <a:avLst/>
@@ -45136,67 +45101,22 @@
           <a:noFill/>
         </p:spPr>
         <p:txBody>
-          <a:bodyPr wrap="square" lIns="0" rIns="0" tIns="0" bIns="0">
+          <a:bodyPr wrap="square" anchor="t" lIns="0" rIns="0" tIns="0" bIns="0">
             <a:spAutoFit/>
           </a:bodyPr>
           <a:lstStyle/>
           <a:p>
             <a:pPr>
               <a:lnSpc>
-                <a:spcPct val="108000"/>
-              </a:lnSpc>
-              <a:spcBef>
-                <a:spcPts val="0"/>
-              </a:spcBef>
-              <a:spcAft>
-                <a:spcPts val="0"/>
-              </a:spcAft>
-            </a:pPr>
-            <a:r>
-              <a:rPr sz="2000" b="0" lang="ja-JP">
-                <a:solidFill>
-                  <a:srgbClr val="303437"/>
-                </a:solidFill>
-                <a:latin typeface="Noto Sans"/>
-                <a:ea typeface="Noto Sans CJK JP"/>
-              </a:rPr>
-              <a:t>10クラスの小規模データで、学習条件を素早く試す。</a:t>
-            </a:r>
-          </a:p>
-        </p:txBody>
-      </p:sp>
-      <p:sp>
-        <p:nvSpPr>
-          <p:cNvPr id="12" name="TextBox 11"/>
-          <p:cNvSpPr txBox="1"/>
-          <p:nvPr/>
-        </p:nvSpPr>
-        <p:spPr>
-          <a:xfrm>
-            <a:off x="594360" y="4489704"/>
-            <a:ext cx="7955279" cy="228600"/>
-          </a:xfrm>
-          <a:prstGeom prst="rect">
-            <a:avLst/>
-          </a:prstGeom>
-          <a:noFill/>
-        </p:spPr>
-        <p:txBody>
-          <a:bodyPr wrap="square" lIns="0" rIns="0" tIns="0" bIns="0">
-            <a:spAutoFit/>
-          </a:bodyPr>
-          <a:lstStyle/>
-          <a:p>
-            <a:pPr>
-              <a:lnSpc>
-                <a:spcPct val="108000"/>
-              </a:lnSpc>
-              <a:spcBef>
-                <a:spcPts val="0"/>
-              </a:spcBef>
-              <a:spcAft>
-                <a:spcPts val="0"/>
-              </a:spcAft>
+                <a:spcPct val="100000"/>
+              </a:lnSpc>
+              <a:spcBef>
+                <a:spcPts val="0"/>
+              </a:spcBef>
+              <a:spcAft>
+                <a:spcPts val="0"/>
+              </a:spcAft>
+              <a:buNone/>
             </a:pPr>
             <a:r>
               <a:rPr sz="1050" b="0" lang="ja-JP">
@@ -45205,9 +45125,9 @@
                 </a:solidFill>
                 <a:latin typeface="Noto Sans"/>
                 <a:ea typeface="Noto Sans CJK JP"/>
-                <a:hlinkClick r:id="rId4"/>
-              </a:rPr>
-              <a:t>https://github.com/fastai/imagenette</a:t>
+                <a:hlinkClick r:id="rId3"/>
+              </a:rPr>
+              <a:t>https://github.com/pytorch/tutorials/blob/main/beginner_source/transfer_learning_tutorial.py</a:t>
             </a:r>
           </a:p>
         </p:txBody>
@@ -45242,12 +45162,14 @@
         </p:nvSpPr>
         <p:spPr/>
         <p:txBody>
-          <a:bodyPr wrap="square" lIns="0" rIns="0" tIns="0" bIns="0" anchor="t"/>
+          <a:bodyPr/>
           <a:lstStyle/>
           <a:p>
             <a:r>
-              <a:rPr sz="2800"/>
-              <a:t>読後の学習・研究に向けて</a:t>
+              <a:rPr sz="2800">
+                <a:latin typeface="Noto Sans"/>
+              </a:rPr>
+              <a:t>参考文献</a:t>
             </a:r>
           </a:p>
         </p:txBody>
@@ -45264,12 +45186,18 @@
         </p:nvSpPr>
         <p:spPr/>
         <p:txBody>
-          <a:bodyPr wrap="square" lIns="0" rIns="0" tIns="0" bIns="0" anchor="ctr"/>
+          <a:bodyPr/>
           <a:lstStyle/>
           <a:p>
             <a:r>
-              <a:rPr sz="1400"/>
-              <a:t>Appendix: 7 参考文献・評価と限界を調べる</a:t>
+              <a:rPr sz="1400" b="1">
+                <a:solidFill>
+                  <a:srgbClr val="FFFEF8"/>
+                </a:solidFill>
+                <a:latin typeface="Noto Sans"/>
+                <a:ea typeface="Noto Sans CJK JP"/>
+              </a:rPr>
+              <a:t>Appendix: 7 参考文献</a:t>
             </a:r>
           </a:p>
         </p:txBody>
@@ -45282,8 +45210,8 @@
         </p:nvSpPr>
         <p:spPr>
           <a:xfrm>
-            <a:off x="594360" y="1353312"/>
-            <a:ext cx="7955279" cy="365760"/>
+            <a:off x="594360" y="1325058"/>
+            <a:ext cx="7955279" cy="455512"/>
           </a:xfrm>
           <a:prstGeom prst="rect">
             <a:avLst/>
@@ -45291,31 +45219,32 @@
           <a:noFill/>
         </p:spPr>
         <p:txBody>
-          <a:bodyPr wrap="square" lIns="0" rIns="0" tIns="0" bIns="0">
+          <a:bodyPr wrap="square" anchor="t" lIns="0" rIns="0" tIns="0" bIns="0">
             <a:spAutoFit/>
           </a:bodyPr>
           <a:lstStyle/>
           <a:p>
             <a:pPr>
               <a:lnSpc>
-                <a:spcPct val="108000"/>
-              </a:lnSpc>
-              <a:spcBef>
-                <a:spcPts val="0"/>
-              </a:spcBef>
-              <a:spcAft>
-                <a:spcPts val="0"/>
-              </a:spcAft>
-            </a:pPr>
-            <a:r>
-              <a:rPr sz="2100" b="1" lang="ja-JP">
+                <a:spcPct val="100000"/>
+              </a:lnSpc>
+              <a:spcBef>
+                <a:spcPts val="0"/>
+              </a:spcBef>
+              <a:spcAft>
+                <a:spcPts val="0"/>
+              </a:spcAft>
+              <a:buNone/>
+            </a:pPr>
+            <a:r>
+              <a:rPr sz="1900" b="1" lang="ja-JP">
                 <a:solidFill>
                   <a:srgbClr val="303437"/>
                 </a:solidFill>
                 <a:latin typeface="Noto Sans"/>
                 <a:ea typeface="Noto Sans CJK JP"/>
               </a:rPr>
-              <a:t>Recht et al. (2019). ImageNetV2. ICML.</a:t>
+              <a:t>Models and pre-trained weights</a:t>
             </a:r>
           </a:p>
         </p:txBody>
@@ -45328,8 +45257,8 @@
         </p:nvSpPr>
         <p:spPr>
           <a:xfrm>
-            <a:off x="594360" y="1746504"/>
-            <a:ext cx="7955279" cy="438912"/>
+            <a:off x="594360" y="1727451"/>
+            <a:ext cx="7955279" cy="375987"/>
           </a:xfrm>
           <a:prstGeom prst="rect">
             <a:avLst/>
@@ -45337,31 +45266,32 @@
           <a:noFill/>
         </p:spPr>
         <p:txBody>
-          <a:bodyPr wrap="square" lIns="0" rIns="0" tIns="0" bIns="0">
+          <a:bodyPr wrap="square" anchor="t" lIns="0" rIns="0" tIns="0" bIns="0">
             <a:spAutoFit/>
           </a:bodyPr>
           <a:lstStyle/>
           <a:p>
             <a:pPr>
               <a:lnSpc>
-                <a:spcPct val="108000"/>
-              </a:lnSpc>
-              <a:spcBef>
-                <a:spcPts val="0"/>
-              </a:spcBef>
-              <a:spcAft>
-                <a:spcPts val="0"/>
-              </a:spcAft>
-            </a:pPr>
-            <a:r>
-              <a:rPr sz="2000" b="0" lang="ja-JP">
+                <a:spcPct val="100000"/>
+              </a:lnSpc>
+              <a:spcBef>
+                <a:spcPts val="0"/>
+              </a:spcBef>
+              <a:spcAft>
+                <a:spcPts val="0"/>
+              </a:spcAft>
+              <a:buNone/>
+            </a:pPr>
+            <a:r>
+              <a:rPr sz="1350" b="0" lang="ja-JP">
                 <a:solidFill>
                   <a:srgbClr val="303437"/>
                 </a:solidFill>
                 <a:latin typeface="Noto Sans"/>
                 <a:ea typeface="Noto Sans CJK JP"/>
               </a:rPr>
-              <a:t>画像を新たに集め直した評価から、汎化性能を調べる。</a:t>
+              <a:t>Torchvision contributors (n.d.). Torchvision documentation. 参照 2026-10-15.</a:t>
             </a:r>
           </a:p>
         </p:txBody>
@@ -45374,8 +45304,8 @@
         </p:nvSpPr>
         <p:spPr>
           <a:xfrm>
-            <a:off x="594360" y="2221991"/>
-            <a:ext cx="7955279" cy="228600"/>
+            <a:off x="594360" y="2075069"/>
+            <a:ext cx="7955279" cy="732332"/>
           </a:xfrm>
           <a:prstGeom prst="rect">
             <a:avLst/>
@@ -45383,32 +45313,32 @@
           <a:noFill/>
         </p:spPr>
         <p:txBody>
-          <a:bodyPr wrap="square" lIns="0" rIns="0" tIns="0" bIns="0">
+          <a:bodyPr wrap="square" anchor="t" lIns="0" rIns="0" tIns="0" bIns="0">
             <a:spAutoFit/>
           </a:bodyPr>
           <a:lstStyle/>
           <a:p>
             <a:pPr>
               <a:lnSpc>
-                <a:spcPct val="108000"/>
-              </a:lnSpc>
-              <a:spcBef>
-                <a:spcPts val="0"/>
-              </a:spcBef>
-              <a:spcAft>
-                <a:spcPts val="0"/>
-              </a:spcAft>
-            </a:pPr>
-            <a:r>
-              <a:rPr sz="1050" b="0" lang="ja-JP">
-                <a:solidFill>
-                  <a:srgbClr val="626669"/>
-                </a:solidFill>
-                <a:latin typeface="Noto Sans"/>
-                <a:ea typeface="Noto Sans CJK JP"/>
-                <a:hlinkClick r:id="rId2"/>
-              </a:rPr>
-              <a:t>https://arxiv.org/abs/1902.10811</a:t>
+                <a:spcPct val="100000"/>
+              </a:lnSpc>
+              <a:spcBef>
+                <a:spcPts val="0"/>
+              </a:spcBef>
+              <a:spcAft>
+                <a:spcPts val="0"/>
+              </a:spcAft>
+              <a:buNone/>
+            </a:pPr>
+            <a:r>
+              <a:rPr sz="1800" b="0" lang="ja-JP">
+                <a:solidFill>
+                  <a:srgbClr val="303437"/>
+                </a:solidFill>
+                <a:latin typeface="Noto Sans"/>
+                <a:ea typeface="Noto Sans CJK JP"/>
+              </a:rPr>
+              <a:t>Torchvisionの公式リファレンス。公開重みの評価値・クラス定義・前処理を記載する。</a:t>
             </a:r>
           </a:p>
         </p:txBody>
@@ -45421,8 +45351,8 @@
         </p:nvSpPr>
         <p:spPr>
           <a:xfrm>
-            <a:off x="594360" y="2487168"/>
-            <a:ext cx="7955279" cy="365760"/>
+            <a:off x="594360" y="2716516"/>
+            <a:ext cx="7955279" cy="308415"/>
           </a:xfrm>
           <a:prstGeom prst="rect">
             <a:avLst/>
@@ -45430,31 +45360,33 @@
           <a:noFill/>
         </p:spPr>
         <p:txBody>
-          <a:bodyPr wrap="square" lIns="0" rIns="0" tIns="0" bIns="0">
+          <a:bodyPr wrap="square" anchor="t" lIns="0" rIns="0" tIns="0" bIns="0">
             <a:spAutoFit/>
           </a:bodyPr>
           <a:lstStyle/>
           <a:p>
             <a:pPr>
               <a:lnSpc>
-                <a:spcPct val="108000"/>
-              </a:lnSpc>
-              <a:spcBef>
-                <a:spcPts val="0"/>
-              </a:spcBef>
-              <a:spcAft>
-                <a:spcPts val="0"/>
-              </a:spcAft>
-            </a:pPr>
-            <a:r>
-              <a:rPr sz="2100" b="1" lang="ja-JP">
-                <a:solidFill>
-                  <a:srgbClr val="303437"/>
-                </a:solidFill>
-                <a:latin typeface="Noto Sans"/>
-                <a:ea typeface="Noto Sans CJK JP"/>
-              </a:rPr>
-              <a:t>Beyer et al. (2020). Are we done with ImageNet?</a:t>
+                <a:spcPct val="100000"/>
+              </a:lnSpc>
+              <a:spcBef>
+                <a:spcPts val="0"/>
+              </a:spcBef>
+              <a:spcAft>
+                <a:spcPts val="0"/>
+              </a:spcAft>
+              <a:buNone/>
+            </a:pPr>
+            <a:r>
+              <a:rPr sz="1050" b="0" lang="ja-JP">
+                <a:solidFill>
+                  <a:srgbClr val="626669"/>
+                </a:solidFill>
+                <a:latin typeface="Noto Sans"/>
+                <a:ea typeface="Noto Sans CJK JP"/>
+                <a:hlinkClick r:id="rId2"/>
+              </a:rPr>
+              <a:t>https://github.com/pytorch/vision/blob/main/docs/source/models.rst</a:t>
             </a:r>
           </a:p>
         </p:txBody>
@@ -45467,8 +45399,8 @@
         </p:nvSpPr>
         <p:spPr>
           <a:xfrm>
-            <a:off x="594360" y="2880360"/>
-            <a:ext cx="7955279" cy="438912"/>
+            <a:off x="594360" y="3133806"/>
+            <a:ext cx="7955279" cy="455512"/>
           </a:xfrm>
           <a:prstGeom prst="rect">
             <a:avLst/>
@@ -45476,31 +45408,32 @@
           <a:noFill/>
         </p:spPr>
         <p:txBody>
-          <a:bodyPr wrap="square" lIns="0" rIns="0" tIns="0" bIns="0">
+          <a:bodyPr wrap="square" anchor="t" lIns="0" rIns="0" tIns="0" bIns="0">
             <a:spAutoFit/>
           </a:bodyPr>
           <a:lstStyle/>
           <a:p>
             <a:pPr>
               <a:lnSpc>
-                <a:spcPct val="108000"/>
-              </a:lnSpc>
-              <a:spcBef>
-                <a:spcPts val="0"/>
-              </a:spcBef>
-              <a:spcAft>
-                <a:spcPts val="0"/>
-              </a:spcAft>
-            </a:pPr>
-            <a:r>
-              <a:rPr sz="2000" b="0" lang="ja-JP">
+                <a:spcPct val="100000"/>
+              </a:lnSpc>
+              <a:spcBef>
+                <a:spcPts val="0"/>
+              </a:spcBef>
+              <a:spcAft>
+                <a:spcPts val="0"/>
+              </a:spcAft>
+              <a:buNone/>
+            </a:pPr>
+            <a:r>
+              <a:rPr sz="1900" b="1" lang="ja-JP">
                 <a:solidFill>
                   <a:srgbClr val="303437"/>
                 </a:solidFill>
                 <a:latin typeface="Noto Sans"/>
                 <a:ea typeface="Noto Sans CJK JP"/>
               </a:rPr>
-              <a:t>複数の正解を許すReaLラベルで、評価の曖昧さを考える。</a:t>
+              <a:t>Imagenette</a:t>
             </a:r>
           </a:p>
         </p:txBody>
@@ -45513,8 +45446,8 @@
         </p:nvSpPr>
         <p:spPr>
           <a:xfrm>
-            <a:off x="594360" y="3355848"/>
-            <a:ext cx="7955279" cy="228600"/>
+            <a:off x="594360" y="3536199"/>
+            <a:ext cx="7955279" cy="375987"/>
           </a:xfrm>
           <a:prstGeom prst="rect">
             <a:avLst/>
@@ -45522,32 +45455,32 @@
           <a:noFill/>
         </p:spPr>
         <p:txBody>
-          <a:bodyPr wrap="square" lIns="0" rIns="0" tIns="0" bIns="0">
+          <a:bodyPr wrap="square" anchor="t" lIns="0" rIns="0" tIns="0" bIns="0">
             <a:spAutoFit/>
           </a:bodyPr>
           <a:lstStyle/>
           <a:p>
             <a:pPr>
               <a:lnSpc>
-                <a:spcPct val="108000"/>
-              </a:lnSpc>
-              <a:spcBef>
-                <a:spcPts val="0"/>
-              </a:spcBef>
-              <a:spcAft>
-                <a:spcPts val="0"/>
-              </a:spcAft>
-            </a:pPr>
-            <a:r>
-              <a:rPr sz="1050" b="0" lang="ja-JP">
-                <a:solidFill>
-                  <a:srgbClr val="626669"/>
-                </a:solidFill>
-                <a:latin typeface="Noto Sans"/>
-                <a:ea typeface="Noto Sans CJK JP"/>
-                <a:hlinkClick r:id="rId3"/>
-              </a:rPr>
-              <a:t>https://arxiv.org/abs/2006.07159</a:t>
+                <a:spcPct val="100000"/>
+              </a:lnSpc>
+              <a:spcBef>
+                <a:spcPts val="0"/>
+              </a:spcBef>
+              <a:spcAft>
+                <a:spcPts val="0"/>
+              </a:spcAft>
+              <a:buNone/>
+            </a:pPr>
+            <a:r>
+              <a:rPr sz="1350" b="0" lang="ja-JP">
+                <a:solidFill>
+                  <a:srgbClr val="303437"/>
+                </a:solidFill>
+                <a:latin typeface="Noto Sans"/>
+                <a:ea typeface="Noto Sans CJK JP"/>
+              </a:rPr>
+              <a:t>fastai (n.d.). GitHub repository. 参照 2026-10-15.</a:t>
             </a:r>
           </a:p>
         </p:txBody>
@@ -45560,8 +45493,8 @@
         </p:nvSpPr>
         <p:spPr>
           <a:xfrm>
-            <a:off x="594360" y="3621024"/>
-            <a:ext cx="7955279" cy="365760"/>
+            <a:off x="594360" y="3883817"/>
+            <a:ext cx="7955279" cy="732332"/>
           </a:xfrm>
           <a:prstGeom prst="rect">
             <a:avLst/>
@@ -45569,31 +45502,32 @@
           <a:noFill/>
         </p:spPr>
         <p:txBody>
-          <a:bodyPr wrap="square" lIns="0" rIns="0" tIns="0" bIns="0">
+          <a:bodyPr wrap="square" anchor="t" lIns="0" rIns="0" tIns="0" bIns="0">
             <a:spAutoFit/>
           </a:bodyPr>
           <a:lstStyle/>
           <a:p>
             <a:pPr>
               <a:lnSpc>
-                <a:spcPct val="108000"/>
-              </a:lnSpc>
-              <a:spcBef>
-                <a:spcPts val="0"/>
-              </a:spcBef>
-              <a:spcAft>
-                <a:spcPts val="0"/>
-              </a:spcAft>
-            </a:pPr>
-            <a:r>
-              <a:rPr sz="2100" b="1" lang="ja-JP">
+                <a:spcPct val="100000"/>
+              </a:lnSpc>
+              <a:spcBef>
+                <a:spcPts val="0"/>
+              </a:spcBef>
+              <a:spcAft>
+                <a:spcPts val="0"/>
+              </a:spcAft>
+              <a:buNone/>
+            </a:pPr>
+            <a:r>
+              <a:rPr sz="1800" b="0" lang="ja-JP">
                 <a:solidFill>
                   <a:srgbClr val="303437"/>
                 </a:solidFill>
                 <a:latin typeface="Noto Sans"/>
                 <a:ea typeface="Noto Sans CJK JP"/>
               </a:rPr>
-              <a:t>Hendrycks &amp; Dietterich (2019). ImageNet-C. ICLR.</a:t>
+              <a:t>ImageNetの10クラスを抜き出した小規模データセット。配布物とベンチマークを公開する。</a:t>
             </a:r>
           </a:p>
         </p:txBody>
@@ -45606,8 +45540,8 @@
         </p:nvSpPr>
         <p:spPr>
           <a:xfrm>
-            <a:off x="594360" y="4014215"/>
-            <a:ext cx="7955279" cy="438912"/>
+            <a:off x="594360" y="4525264"/>
+            <a:ext cx="7955279" cy="308415"/>
           </a:xfrm>
           <a:prstGeom prst="rect">
             <a:avLst/>
@@ -45615,45 +45549,117 @@
           <a:noFill/>
         </p:spPr>
         <p:txBody>
-          <a:bodyPr wrap="square" lIns="0" rIns="0" tIns="0" bIns="0">
+          <a:bodyPr wrap="square" anchor="t" lIns="0" rIns="0" tIns="0" bIns="0">
             <a:spAutoFit/>
           </a:bodyPr>
           <a:lstStyle/>
           <a:p>
             <a:pPr>
               <a:lnSpc>
-                <a:spcPct val="108000"/>
-              </a:lnSpc>
-              <a:spcBef>
-                <a:spcPts val="0"/>
-              </a:spcBef>
-              <a:spcAft>
-                <a:spcPts val="0"/>
-              </a:spcAft>
-            </a:pPr>
-            <a:r>
-              <a:rPr sz="2000" b="0" lang="ja-JP">
-                <a:solidFill>
-                  <a:srgbClr val="303437"/>
-                </a:solidFill>
-                <a:latin typeface="Noto Sans"/>
-                <a:ea typeface="Noto Sans CJK JP"/>
-              </a:rPr>
-              <a:t>汚損・ぼけ・天候変化への頑健性を、分類精度と分けて評価する。</a:t>
-            </a:r>
-          </a:p>
-        </p:txBody>
-      </p:sp>
-      <p:sp>
-        <p:nvSpPr>
-          <p:cNvPr id="12" name="TextBox 11"/>
+                <a:spcPct val="100000"/>
+              </a:lnSpc>
+              <a:spcBef>
+                <a:spcPts val="0"/>
+              </a:spcBef>
+              <a:spcAft>
+                <a:spcPts val="0"/>
+              </a:spcAft>
+              <a:buNone/>
+            </a:pPr>
+            <a:r>
+              <a:rPr sz="1050" b="0" lang="ja-JP">
+                <a:solidFill>
+                  <a:srgbClr val="626669"/>
+                </a:solidFill>
+                <a:latin typeface="Noto Sans"/>
+                <a:ea typeface="Noto Sans CJK JP"/>
+                <a:hlinkClick r:id="rId3"/>
+              </a:rPr>
+              <a:t>https://github.com/fastai/imagenette</a:t>
+            </a:r>
+          </a:p>
+        </p:txBody>
+      </p:sp>
+    </p:spTree>
+  </p:cSld>
+  <p:clrMapOvr>
+    <a:masterClrMapping/>
+  </p:clrMapOvr>
+</p:sld>
+</file>
+
+<file path=ppt/slides/slide68.xml><?xml version="1.0" encoding="utf-8"?>
+<p:sld xmlns:a="http://schemas.openxmlformats.org/drawingml/2006/main" xmlns:p="http://schemas.openxmlformats.org/presentationml/2006/main" xmlns:r="http://schemas.openxmlformats.org/officeDocument/2006/relationships">
+  <p:cSld>
+    <p:spTree>
+      <p:nvGrpSpPr>
+        <p:cNvPr id="1" name=""/>
+        <p:cNvGrpSpPr/>
+        <p:nvPr/>
+      </p:nvGrpSpPr>
+      <p:grpSpPr/>
+      <p:sp>
+        <p:nvSpPr>
+          <p:cNvPr id="2" name="Title 1"/>
+          <p:cNvSpPr>
+            <a:spLocks noGrp="1"/>
+          </p:cNvSpPr>
+          <p:nvPr>
+            <p:ph type="title"/>
+          </p:nvPr>
+        </p:nvSpPr>
+        <p:spPr/>
+        <p:txBody>
+          <a:bodyPr/>
+          <a:lstStyle/>
+          <a:p>
+            <a:r>
+              <a:rPr sz="2800">
+                <a:latin typeface="Noto Sans"/>
+              </a:rPr>
+              <a:t>参考文献</a:t>
+            </a:r>
+          </a:p>
+        </p:txBody>
+      </p:sp>
+      <p:sp>
+        <p:nvSpPr>
+          <p:cNvPr id="3" name="Title 2"/>
+          <p:cNvSpPr>
+            <a:spLocks noGrp="1"/>
+          </p:cNvSpPr>
+          <p:nvPr>
+            <p:ph type="title" idx="2"/>
+          </p:nvPr>
+        </p:nvSpPr>
+        <p:spPr/>
+        <p:txBody>
+          <a:bodyPr/>
+          <a:lstStyle/>
+          <a:p>
+            <a:r>
+              <a:rPr sz="1400" b="1">
+                <a:solidFill>
+                  <a:srgbClr val="FFFEF8"/>
+                </a:solidFill>
+                <a:latin typeface="Noto Sans"/>
+                <a:ea typeface="Noto Sans CJK JP"/>
+              </a:rPr>
+              <a:t>Appendix: 7 参考文献</a:t>
+            </a:r>
+          </a:p>
+        </p:txBody>
+      </p:sp>
+      <p:sp>
+        <p:nvSpPr>
+          <p:cNvPr id="4" name="TextBox 3"/>
           <p:cNvSpPr txBox="1"/>
           <p:nvPr/>
         </p:nvSpPr>
         <p:spPr>
           <a:xfrm>
-            <a:off x="594360" y="4489704"/>
-            <a:ext cx="7955279" cy="228600"/>
+            <a:off x="594360" y="1325058"/>
+            <a:ext cx="7955279" cy="455512"/>
           </a:xfrm>
           <a:prstGeom prst="rect">
             <a:avLst/>
@@ -45661,21 +45667,163 @@
           <a:noFill/>
         </p:spPr>
         <p:txBody>
-          <a:bodyPr wrap="square" lIns="0" rIns="0" tIns="0" bIns="0">
+          <a:bodyPr wrap="square" anchor="t" lIns="0" rIns="0" tIns="0" bIns="0">
             <a:spAutoFit/>
           </a:bodyPr>
           <a:lstStyle/>
           <a:p>
             <a:pPr>
               <a:lnSpc>
-                <a:spcPct val="108000"/>
-              </a:lnSpc>
-              <a:spcBef>
-                <a:spcPts val="0"/>
-              </a:spcBef>
-              <a:spcAft>
-                <a:spcPts val="0"/>
-              </a:spcAft>
+                <a:spcPct val="100000"/>
+              </a:lnSpc>
+              <a:spcBef>
+                <a:spcPts val="0"/>
+              </a:spcBef>
+              <a:spcAft>
+                <a:spcPts val="0"/>
+              </a:spcAft>
+              <a:buNone/>
+            </a:pPr>
+            <a:r>
+              <a:rPr sz="1900" b="1" lang="ja-JP">
+                <a:solidFill>
+                  <a:srgbClr val="303437"/>
+                </a:solidFill>
+                <a:latin typeface="Noto Sans"/>
+                <a:ea typeface="Noto Sans CJK JP"/>
+              </a:rPr>
+              <a:t>Do ImageNet Classifiers Generalize to ImageNet?</a:t>
+            </a:r>
+          </a:p>
+        </p:txBody>
+      </p:sp>
+      <p:sp>
+        <p:nvSpPr>
+          <p:cNvPr id="5" name="TextBox 4"/>
+          <p:cNvSpPr txBox="1"/>
+          <p:nvPr/>
+        </p:nvSpPr>
+        <p:spPr>
+          <a:xfrm>
+            <a:off x="594360" y="1711857"/>
+            <a:ext cx="7955279" cy="565955"/>
+          </a:xfrm>
+          <a:prstGeom prst="rect">
+            <a:avLst/>
+          </a:prstGeom>
+          <a:noFill/>
+        </p:spPr>
+        <p:txBody>
+          <a:bodyPr wrap="square" anchor="t" lIns="0" rIns="0" tIns="0" bIns="0">
+            <a:spAutoFit/>
+          </a:bodyPr>
+          <a:lstStyle/>
+          <a:p>
+            <a:pPr>
+              <a:lnSpc>
+                <a:spcPct val="100000"/>
+              </a:lnSpc>
+              <a:spcBef>
+                <a:spcPts val="0"/>
+              </a:spcBef>
+              <a:spcAft>
+                <a:spcPts val="0"/>
+              </a:spcAft>
+              <a:buNone/>
+            </a:pPr>
+            <a:r>
+              <a:rPr sz="1350" b="0" lang="ja-JP">
+                <a:solidFill>
+                  <a:srgbClr val="303437"/>
+                </a:solidFill>
+                <a:latin typeface="Noto Sans"/>
+                <a:ea typeface="Noto Sans CJK JP"/>
+              </a:rPr>
+              <a:t>Recht, B., Roelofs, R., Schmidt, L., &amp; Shankar, V. (2019). ICML, Proceedings of Machine Learning Research, 97.</a:t>
+            </a:r>
+          </a:p>
+        </p:txBody>
+      </p:sp>
+      <p:sp>
+        <p:nvSpPr>
+          <p:cNvPr id="6" name="TextBox 5"/>
+          <p:cNvSpPr txBox="1"/>
+          <p:nvPr/>
+        </p:nvSpPr>
+        <p:spPr>
+          <a:xfrm>
+            <a:off x="594360" y="2265037"/>
+            <a:ext cx="7955279" cy="732332"/>
+          </a:xfrm>
+          <a:prstGeom prst="rect">
+            <a:avLst/>
+          </a:prstGeom>
+          <a:noFill/>
+        </p:spPr>
+        <p:txBody>
+          <a:bodyPr wrap="square" anchor="t" lIns="0" rIns="0" tIns="0" bIns="0">
+            <a:spAutoFit/>
+          </a:bodyPr>
+          <a:lstStyle/>
+          <a:p>
+            <a:pPr>
+              <a:lnSpc>
+                <a:spcPct val="100000"/>
+              </a:lnSpc>
+              <a:spcBef>
+                <a:spcPts val="0"/>
+              </a:spcBef>
+              <a:spcAft>
+                <a:spcPts val="0"/>
+              </a:spcAft>
+              <a:buNone/>
+            </a:pPr>
+            <a:r>
+              <a:rPr sz="1800" b="0" lang="ja-JP">
+                <a:solidFill>
+                  <a:srgbClr val="303437"/>
+                </a:solidFill>
+                <a:latin typeface="Noto Sans"/>
+                <a:ea typeface="Noto Sans CJK JP"/>
+              </a:rPr>
+              <a:t>ImageNetV2の原著論文。新たに収集した画像で既存分類器の汎化性能を検証する。</a:t>
+            </a:r>
+          </a:p>
+        </p:txBody>
+      </p:sp>
+      <p:sp>
+        <p:nvSpPr>
+          <p:cNvPr id="7" name="TextBox 6"/>
+          <p:cNvSpPr txBox="1"/>
+          <p:nvPr/>
+        </p:nvSpPr>
+        <p:spPr>
+          <a:xfrm>
+            <a:off x="594360" y="2906484"/>
+            <a:ext cx="7955279" cy="308415"/>
+          </a:xfrm>
+          <a:prstGeom prst="rect">
+            <a:avLst/>
+          </a:prstGeom>
+          <a:noFill/>
+        </p:spPr>
+        <p:txBody>
+          <a:bodyPr wrap="square" anchor="t" lIns="0" rIns="0" tIns="0" bIns="0">
+            <a:spAutoFit/>
+          </a:bodyPr>
+          <a:lstStyle/>
+          <a:p>
+            <a:pPr>
+              <a:lnSpc>
+                <a:spcPct val="100000"/>
+              </a:lnSpc>
+              <a:spcBef>
+                <a:spcPts val="0"/>
+              </a:spcBef>
+              <a:spcAft>
+                <a:spcPts val="0"/>
+              </a:spcAft>
+              <a:buNone/>
             </a:pPr>
             <a:r>
               <a:rPr sz="1050" b="0" lang="ja-JP">
@@ -45684,7 +45832,455 @@
                 </a:solidFill>
                 <a:latin typeface="Noto Sans"/>
                 <a:ea typeface="Noto Sans CJK JP"/>
-                <a:hlinkClick r:id="rId4"/>
+                <a:hlinkClick r:id="rId2"/>
+              </a:rPr>
+              <a:t>https://arxiv.org/abs/1902.10811</a:t>
+            </a:r>
+          </a:p>
+        </p:txBody>
+      </p:sp>
+      <p:sp>
+        <p:nvSpPr>
+          <p:cNvPr id="8" name="TextBox 7"/>
+          <p:cNvSpPr txBox="1"/>
+          <p:nvPr/>
+        </p:nvSpPr>
+        <p:spPr>
+          <a:xfrm>
+            <a:off x="594360" y="3323774"/>
+            <a:ext cx="7955279" cy="455512"/>
+          </a:xfrm>
+          <a:prstGeom prst="rect">
+            <a:avLst/>
+          </a:prstGeom>
+          <a:noFill/>
+        </p:spPr>
+        <p:txBody>
+          <a:bodyPr wrap="square" anchor="t" lIns="0" rIns="0" tIns="0" bIns="0">
+            <a:spAutoFit/>
+          </a:bodyPr>
+          <a:lstStyle/>
+          <a:p>
+            <a:pPr>
+              <a:lnSpc>
+                <a:spcPct val="100000"/>
+              </a:lnSpc>
+              <a:spcBef>
+                <a:spcPts val="0"/>
+              </a:spcBef>
+              <a:spcAft>
+                <a:spcPts val="0"/>
+              </a:spcAft>
+              <a:buNone/>
+            </a:pPr>
+            <a:r>
+              <a:rPr sz="1900" b="1" lang="ja-JP">
+                <a:solidFill>
+                  <a:srgbClr val="303437"/>
+                </a:solidFill>
+                <a:latin typeface="Noto Sans"/>
+                <a:ea typeface="Noto Sans CJK JP"/>
+              </a:rPr>
+              <a:t>Are we done with ImageNet?</a:t>
+            </a:r>
+          </a:p>
+        </p:txBody>
+      </p:sp>
+      <p:sp>
+        <p:nvSpPr>
+          <p:cNvPr id="9" name="TextBox 8"/>
+          <p:cNvSpPr txBox="1"/>
+          <p:nvPr/>
+        </p:nvSpPr>
+        <p:spPr>
+          <a:xfrm>
+            <a:off x="594360" y="3710573"/>
+            <a:ext cx="7955279" cy="360393"/>
+          </a:xfrm>
+          <a:prstGeom prst="rect">
+            <a:avLst/>
+          </a:prstGeom>
+          <a:noFill/>
+        </p:spPr>
+        <p:txBody>
+          <a:bodyPr wrap="square" anchor="t" lIns="0" rIns="0" tIns="0" bIns="0">
+            <a:spAutoFit/>
+          </a:bodyPr>
+          <a:lstStyle/>
+          <a:p>
+            <a:pPr>
+              <a:lnSpc>
+                <a:spcPct val="100000"/>
+              </a:lnSpc>
+              <a:spcBef>
+                <a:spcPts val="0"/>
+              </a:spcBef>
+              <a:spcAft>
+                <a:spcPts val="0"/>
+              </a:spcAft>
+              <a:buNone/>
+            </a:pPr>
+            <a:r>
+              <a:rPr sz="1350" b="0" lang="ja-JP">
+                <a:solidFill>
+                  <a:srgbClr val="303437"/>
+                </a:solidFill>
+                <a:latin typeface="Noto Sans"/>
+                <a:ea typeface="Noto Sans CJK JP"/>
+              </a:rPr>
+              <a:t>Beyer, L., Hénaff, O. J., Kolesnikov, A., Zhai, X., &amp; van den Oord, A. (2020). arXiv:2006.07159.</a:t>
+            </a:r>
+          </a:p>
+        </p:txBody>
+      </p:sp>
+      <p:sp>
+        <p:nvSpPr>
+          <p:cNvPr id="10" name="TextBox 9"/>
+          <p:cNvSpPr txBox="1"/>
+          <p:nvPr/>
+        </p:nvSpPr>
+        <p:spPr>
+          <a:xfrm>
+            <a:off x="594360" y="4058191"/>
+            <a:ext cx="7955279" cy="732332"/>
+          </a:xfrm>
+          <a:prstGeom prst="rect">
+            <a:avLst/>
+          </a:prstGeom>
+          <a:noFill/>
+        </p:spPr>
+        <p:txBody>
+          <a:bodyPr wrap="square" anchor="t" lIns="0" rIns="0" tIns="0" bIns="0">
+            <a:spAutoFit/>
+          </a:bodyPr>
+          <a:lstStyle/>
+          <a:p>
+            <a:pPr>
+              <a:lnSpc>
+                <a:spcPct val="100000"/>
+              </a:lnSpc>
+              <a:spcBef>
+                <a:spcPts val="0"/>
+              </a:spcBef>
+              <a:spcAft>
+                <a:spcPts val="0"/>
+              </a:spcAft>
+              <a:buNone/>
+            </a:pPr>
+            <a:r>
+              <a:rPr sz="1800" b="0" lang="ja-JP">
+                <a:solidFill>
+                  <a:srgbClr val="303437"/>
+                </a:solidFill>
+                <a:latin typeface="Noto Sans"/>
+                <a:ea typeface="Noto Sans CJK JP"/>
+              </a:rPr>
+              <a:t>検証画像の正解を再注釈した研究。複数の物体を正解とするReaLラベルを提案する。</a:t>
+            </a:r>
+          </a:p>
+        </p:txBody>
+      </p:sp>
+      <p:sp>
+        <p:nvSpPr>
+          <p:cNvPr id="11" name="TextBox 10"/>
+          <p:cNvSpPr txBox="1"/>
+          <p:nvPr/>
+        </p:nvSpPr>
+        <p:spPr>
+          <a:xfrm>
+            <a:off x="594360" y="4699638"/>
+            <a:ext cx="7955279" cy="308415"/>
+          </a:xfrm>
+          <a:prstGeom prst="rect">
+            <a:avLst/>
+          </a:prstGeom>
+          <a:noFill/>
+        </p:spPr>
+        <p:txBody>
+          <a:bodyPr wrap="square" anchor="t" lIns="0" rIns="0" tIns="0" bIns="0">
+            <a:spAutoFit/>
+          </a:bodyPr>
+          <a:lstStyle/>
+          <a:p>
+            <a:pPr>
+              <a:lnSpc>
+                <a:spcPct val="100000"/>
+              </a:lnSpc>
+              <a:spcBef>
+                <a:spcPts val="0"/>
+              </a:spcBef>
+              <a:spcAft>
+                <a:spcPts val="0"/>
+              </a:spcAft>
+              <a:buNone/>
+            </a:pPr>
+            <a:r>
+              <a:rPr sz="1050" b="0" lang="ja-JP">
+                <a:solidFill>
+                  <a:srgbClr val="626669"/>
+                </a:solidFill>
+                <a:latin typeface="Noto Sans"/>
+                <a:ea typeface="Noto Sans CJK JP"/>
+                <a:hlinkClick r:id="rId3"/>
+              </a:rPr>
+              <a:t>https://arxiv.org/abs/2006.07159</a:t>
+            </a:r>
+          </a:p>
+        </p:txBody>
+      </p:sp>
+    </p:spTree>
+  </p:cSld>
+  <p:clrMapOvr>
+    <a:masterClrMapping/>
+  </p:clrMapOvr>
+</p:sld>
+</file>
+
+<file path=ppt/slides/slide69.xml><?xml version="1.0" encoding="utf-8"?>
+<p:sld xmlns:a="http://schemas.openxmlformats.org/drawingml/2006/main" xmlns:p="http://schemas.openxmlformats.org/presentationml/2006/main" xmlns:r="http://schemas.openxmlformats.org/officeDocument/2006/relationships">
+  <p:cSld>
+    <p:spTree>
+      <p:nvGrpSpPr>
+        <p:cNvPr id="1" name=""/>
+        <p:cNvGrpSpPr/>
+        <p:nvPr/>
+      </p:nvGrpSpPr>
+      <p:grpSpPr/>
+      <p:sp>
+        <p:nvSpPr>
+          <p:cNvPr id="2" name="Title 1"/>
+          <p:cNvSpPr>
+            <a:spLocks noGrp="1"/>
+          </p:cNvSpPr>
+          <p:nvPr>
+            <p:ph type="title"/>
+          </p:nvPr>
+        </p:nvSpPr>
+        <p:spPr/>
+        <p:txBody>
+          <a:bodyPr/>
+          <a:lstStyle/>
+          <a:p>
+            <a:r>
+              <a:rPr sz="2800">
+                <a:latin typeface="Noto Sans"/>
+              </a:rPr>
+              <a:t>参考文献</a:t>
+            </a:r>
+          </a:p>
+        </p:txBody>
+      </p:sp>
+      <p:sp>
+        <p:nvSpPr>
+          <p:cNvPr id="3" name="Title 2"/>
+          <p:cNvSpPr>
+            <a:spLocks noGrp="1"/>
+          </p:cNvSpPr>
+          <p:nvPr>
+            <p:ph type="title" idx="2"/>
+          </p:nvPr>
+        </p:nvSpPr>
+        <p:spPr/>
+        <p:txBody>
+          <a:bodyPr/>
+          <a:lstStyle/>
+          <a:p>
+            <a:r>
+              <a:rPr sz="1400" b="1">
+                <a:solidFill>
+                  <a:srgbClr val="FFFEF8"/>
+                </a:solidFill>
+                <a:latin typeface="Noto Sans"/>
+                <a:ea typeface="Noto Sans CJK JP"/>
+              </a:rPr>
+              <a:t>Appendix: 7 参考文献</a:t>
+            </a:r>
+          </a:p>
+        </p:txBody>
+      </p:sp>
+      <p:sp>
+        <p:nvSpPr>
+          <p:cNvPr id="4" name="TextBox 3"/>
+          <p:cNvSpPr txBox="1"/>
+          <p:nvPr/>
+        </p:nvSpPr>
+        <p:spPr>
+          <a:xfrm>
+            <a:off x="594360" y="1327691"/>
+            <a:ext cx="7955279" cy="842643"/>
+          </a:xfrm>
+          <a:prstGeom prst="rect">
+            <a:avLst/>
+          </a:prstGeom>
+          <a:noFill/>
+        </p:spPr>
+        <p:txBody>
+          <a:bodyPr wrap="square" anchor="t" lIns="0" rIns="0" tIns="0" bIns="0">
+            <a:spAutoFit/>
+          </a:bodyPr>
+          <a:lstStyle/>
+          <a:p>
+            <a:pPr>
+              <a:lnSpc>
+                <a:spcPct val="100000"/>
+              </a:lnSpc>
+              <a:spcBef>
+                <a:spcPts val="0"/>
+              </a:spcBef>
+              <a:spcAft>
+                <a:spcPts val="0"/>
+              </a:spcAft>
+              <a:buNone/>
+            </a:pPr>
+            <a:r>
+              <a:rPr sz="2200" b="1" lang="ja-JP">
+                <a:solidFill>
+                  <a:srgbClr val="303437"/>
+                </a:solidFill>
+                <a:latin typeface="Noto Sans"/>
+                <a:ea typeface="Noto Sans CJK JP"/>
+              </a:rPr>
+              <a:t>Benchmarking Neural Network Robustness to Common Corruptions and Perturbations</a:t>
+            </a:r>
+          </a:p>
+        </p:txBody>
+      </p:sp>
+      <p:sp>
+        <p:nvSpPr>
+          <p:cNvPr id="5" name="TextBox 4"/>
+          <p:cNvSpPr txBox="1"/>
+          <p:nvPr/>
+        </p:nvSpPr>
+        <p:spPr>
+          <a:xfrm>
+            <a:off x="594360" y="2100753"/>
+            <a:ext cx="7955279" cy="395213"/>
+          </a:xfrm>
+          <a:prstGeom prst="rect">
+            <a:avLst/>
+          </a:prstGeom>
+          <a:noFill/>
+        </p:spPr>
+        <p:txBody>
+          <a:bodyPr wrap="square" anchor="t" lIns="0" rIns="0" tIns="0" bIns="0">
+            <a:spAutoFit/>
+          </a:bodyPr>
+          <a:lstStyle/>
+          <a:p>
+            <a:pPr>
+              <a:lnSpc>
+                <a:spcPct val="100000"/>
+              </a:lnSpc>
+              <a:spcBef>
+                <a:spcPts val="0"/>
+              </a:spcBef>
+              <a:spcAft>
+                <a:spcPts val="0"/>
+              </a:spcAft>
+              <a:buNone/>
+            </a:pPr>
+            <a:r>
+              <a:rPr sz="1550" b="0" lang="ja-JP">
+                <a:solidFill>
+                  <a:srgbClr val="303437"/>
+                </a:solidFill>
+                <a:latin typeface="Noto Sans"/>
+                <a:ea typeface="Noto Sans CJK JP"/>
+              </a:rPr>
+              <a:t>Hendrycks, D., &amp; Dietterich, T. (2019). ICLR.</a:t>
+            </a:r>
+          </a:p>
+        </p:txBody>
+      </p:sp>
+      <p:sp>
+        <p:nvSpPr>
+          <p:cNvPr id="6" name="TextBox 5"/>
+          <p:cNvSpPr txBox="1"/>
+          <p:nvPr/>
+        </p:nvSpPr>
+        <p:spPr>
+          <a:xfrm>
+            <a:off x="594360" y="2485529"/>
+            <a:ext cx="7955279" cy="799958"/>
+          </a:xfrm>
+          <a:prstGeom prst="rect">
+            <a:avLst/>
+          </a:prstGeom>
+          <a:noFill/>
+        </p:spPr>
+        <p:txBody>
+          <a:bodyPr wrap="square" anchor="t" lIns="0" rIns="0" tIns="0" bIns="0">
+            <a:spAutoFit/>
+          </a:bodyPr>
+          <a:lstStyle/>
+          <a:p>
+            <a:pPr>
+              <a:lnSpc>
+                <a:spcPct val="100000"/>
+              </a:lnSpc>
+              <a:spcBef>
+                <a:spcPts val="0"/>
+              </a:spcBef>
+              <a:spcAft>
+                <a:spcPts val="0"/>
+              </a:spcAft>
+              <a:buNone/>
+            </a:pPr>
+            <a:r>
+              <a:rPr sz="2000" b="0" lang="ja-JP">
+                <a:solidFill>
+                  <a:srgbClr val="303437"/>
+                </a:solidFill>
+                <a:latin typeface="Noto Sans"/>
+                <a:ea typeface="Noto Sans CJK JP"/>
+              </a:rPr>
+              <a:t>ImageNet-CとImageNet-Pの提案論文。汚損や連続的な変化に対する頑健性を評価する。</a:t>
+            </a:r>
+          </a:p>
+        </p:txBody>
+      </p:sp>
+      <p:sp>
+        <p:nvSpPr>
+          <p:cNvPr id="7" name="TextBox 6"/>
+          <p:cNvSpPr txBox="1"/>
+          <p:nvPr/>
+        </p:nvSpPr>
+        <p:spPr>
+          <a:xfrm>
+            <a:off x="594360" y="3190946"/>
+            <a:ext cx="7955279" cy="317236"/>
+          </a:xfrm>
+          <a:prstGeom prst="rect">
+            <a:avLst/>
+          </a:prstGeom>
+          <a:noFill/>
+        </p:spPr>
+        <p:txBody>
+          <a:bodyPr wrap="square" anchor="t" lIns="0" rIns="0" tIns="0" bIns="0">
+            <a:spAutoFit/>
+          </a:bodyPr>
+          <a:lstStyle/>
+          <a:p>
+            <a:pPr>
+              <a:lnSpc>
+                <a:spcPct val="100000"/>
+              </a:lnSpc>
+              <a:spcBef>
+                <a:spcPts val="0"/>
+              </a:spcBef>
+              <a:spcAft>
+                <a:spcPts val="0"/>
+              </a:spcAft>
+              <a:buNone/>
+            </a:pPr>
+            <a:r>
+              <a:rPr sz="1100" b="0" lang="ja-JP">
+                <a:solidFill>
+                  <a:srgbClr val="626669"/>
+                </a:solidFill>
+                <a:latin typeface="Noto Sans"/>
+                <a:ea typeface="Noto Sans CJK JP"/>
+                <a:hlinkClick r:id="rId2"/>
               </a:rPr>
               <a:t>https://arxiv.org/abs/1903.12261</a:t>
             </a:r>

</xml_diff>

<commit_message>
Proofread imagenet with Japanese proofreading skill
</commit_message>
<xml_diff>
--- a/slides/datasets-in-10-minutes-imagenet.pptx
+++ b/slides/datasets-in-10-minutes-imagenet.pptx
@@ -8020,7 +8020,7 @@
                 <a:ea typeface="Noto Sans CJK JP"/>
                 <a:cs typeface="Noto Sans"/>
               </a:rPr>
-              <a:t>犬種を表すクラスである。犬という上位概念より、細かな区別を求める。</a:t>
+              <a:t>犬種を表すクラスである。犬という上位概念よりも細かな区別が求められる。</a:t>
             </a:r>
             <a:endParaRPr sz="2100" lang="ja-JP">
               <a:latin typeface="Noto Sans"/>
@@ -9661,7 +9661,7 @@
                 <a:ea typeface="Noto Sans CJK JP"/>
                 <a:cs typeface="Noto Sans"/>
               </a:rPr>
-              <a:t>有償作業のAmazon Mechanical Turkを使った </a:t>
+              <a:t>有償クラウドソーシングのAmazon Mechanical Turkを使った </a:t>
             </a:r>
             <a:r>
               <a:rPr sz="2400" lang="ja-JP">
@@ -9776,18 +9776,18 @@
             </a:endParaRPr>
           </a:p>
           <a:p>
-            <a:pPr algn="l" lvl="0" marL="457200" indent="-355600">
-              <a:buSzPct val="55417"/>
+            <a:pPr algn="l" lvl="1" marL="914400" indent="-355600">
+              <a:buSzPct val="63333"/>
               <a:buFont typeface="Noto Sans CJK JP"/>
-              <a:buChar char="●"/>
-              <a:defRPr sz="2400" lang="ja-JP">
-                <a:latin typeface="Noto Sans"/>
-                <a:ea typeface="Noto Sans CJK JP"/>
-                <a:cs typeface="Noto Sans"/>
-              </a:defRPr>
-            </a:pPr>
-            <a:r>
-              <a:rPr sz="2400" lang="ja-JP">
+              <a:buChar char="○"/>
+              <a:defRPr sz="2100" lang="ja-JP">
+                <a:latin typeface="Noto Sans"/>
+                <a:ea typeface="Noto Sans CJK JP"/>
+                <a:cs typeface="Noto Sans"/>
+              </a:defRPr>
+            </a:pPr>
+            <a:r>
+              <a:rPr sz="2100" lang="ja-JP">
                 <a:solidFill>
                   <a:srgbClr val="303437"/>
                 </a:solidFill>
@@ -9797,7 +9797,7 @@
               </a:rPr>
               <a:t>見やすい単独物体だけに限定しなかった。</a:t>
             </a:r>
-            <a:endParaRPr sz="2400" lang="ja-JP">
+            <a:endParaRPr sz="2100" lang="ja-JP">
               <a:latin typeface="Noto Sans"/>
               <a:ea typeface="Noto Sans CJK JP"/>
               <a:cs typeface="Noto Sans"/>
@@ -13967,7 +13967,7 @@
                 <a:ea typeface="Noto Sans CJK JP"/>
                 <a:cs typeface="Noto Sans"/>
               </a:rPr>
-              <a:t>順位に応じてTop-1とTop-5が変わる</a:t>
+              <a:t>順位に応じてTop-1とTop-5の得点が変わる</a:t>
             </a:r>
             <a:endParaRPr sz="2800" lang="ja-JP">
               <a:latin typeface="Noto Sans"/>
@@ -17320,7 +17320,7 @@
                 <a:ea typeface="Noto Sans CJK JP"/>
                 <a:cs typeface="Noto Sans"/>
               </a:rPr>
-              <a:t>残差接続を用いるResNetの、10クロップ評価による値。同じ画像から10領域を切り出し、予測をまとめる。</a:t>
+              <a:t>残差接続を用いるResNetをImageNetの検証用データで10クロップ評価した値。同じ画像から10領域を切り出し、予測を統合する。</a:t>
             </a:r>
             <a:endParaRPr sz="1600" lang="ja-JP">
               <a:latin typeface="Noto Sans"/>
@@ -18391,7 +18391,7 @@
                 <a:ea typeface="Noto Sans CJK JP"/>
                 <a:cs typeface="Noto Sans"/>
               </a:rPr>
-              <a:t>特徴モデルを固定し、ImageNetの学習用で線形分類器を学習する。検証用で条件を選び、同じ検証用で評価する。入力解像度は異なる。</a:t>
+              <a:t>特徴モデルを固定し、ImageNetの学習データで線形分類器を学習する。検証データで条件を選び、同じ検証データで評価する。入力解像度はモデルごとに異なる。</a:t>
             </a:r>
             <a:endParaRPr sz="1600" lang="ja-JP">
               <a:latin typeface="Noto Sans"/>
@@ -19695,7 +19695,7 @@
                 <a:ea typeface="Noto Sans CJK JP"/>
                 <a:cs typeface="Noto Sans"/>
               </a:rPr>
-              <a:t>[2]</a:t>
+              <a:t>[1]</a:t>
             </a:r>
             <a:r>
               <a:rPr sz="2200" lang="ja-JP">
@@ -20490,7 +20490,7 @@
                 <a:ea typeface="Noto Sans CJK JP"/>
                 <a:cs typeface="Noto Sans"/>
               </a:rPr>
-              <a:t>その後、絵画のImageNet-Rや、画像を劣化させたImageNet-Cも作られた [2]。</a:t>
+              <a:t>絵画のImageNet-Rや、画像を劣化させたImageNet-Cも作られた。</a:t>
             </a:r>
             <a:r>
               <a:rPr sz="2100" lang="ja-JP">
@@ -20540,7 +20540,7 @@
                 <a:ea typeface="Noto Sans CJK JP"/>
                 <a:cs typeface="Noto Sans"/>
               </a:rPr>
-              <a:t>2025年のDINOv3論文も、これらで汎化性能を調べている。</a:t>
+              <a:t>2025年のDINOv3論文も、これらで汎化性能を調べている [2]。</a:t>
             </a:r>
             <a:endParaRPr sz="2100" lang="ja-JP">
               <a:latin typeface="Noto Sans"/>
@@ -20568,7 +20568,7 @@
                 <a:ea typeface="Noto Sans CJK JP"/>
                 <a:cs typeface="Noto Sans"/>
               </a:rPr>
-              <a:t>2026年も公開実装に、ImageNetでの評価手順がある </a:t>
+              <a:t>2026年の公開実装にも、ImageNetでの評価手順が含まれる </a:t>
             </a:r>
             <a:r>
               <a:rPr sz="2100" lang="ja-JP">
@@ -21404,7 +21404,7 @@
                 <a:ea typeface="Noto Sans CJK JP"/>
                 <a:cs typeface="Noto Sans"/>
               </a:rPr>
-              <a:t>2009年に発表され、多数の画像を人手で確認した。</a:t>
+              <a:t>2009年に発表され、多数の画像が人手で確認された。</a:t>
             </a:r>
             <a:endParaRPr sz="2400" lang="ja-JP">
               <a:latin typeface="Noto Sans"/>
@@ -21460,7 +21460,7 @@
                 <a:ea typeface="Noto Sans CJK JP"/>
                 <a:cs typeface="Noto Sans"/>
               </a:rPr>
-              <a:t>現在は特徴評価にも使い、汎化は別画像で調べる。</a:t>
+              <a:t>現在は特徴評価にも使われ、汎化性能は別画像で調べる。</a:t>
             </a:r>
             <a:endParaRPr sz="2400" lang="ja-JP">
               <a:latin typeface="Noto Sans"/>
@@ -24239,7 +24239,7 @@
                 <a:ea typeface="Noto Sans CJK JP"/>
                 <a:cs typeface="Noto Sans"/>
               </a:rPr>
-              <a:t>爬虫類と両生類と魚類と水生無脊椎動物のカテゴリ</a:t>
+              <a:t>爬虫類・両生類・魚類・水生無脊椎動物の例</a:t>
             </a:r>
             <a:endParaRPr sz="2800" lang="ja-JP">
               <a:latin typeface="Noto Sans"/>
@@ -25776,7 +25776,7 @@
                 <a:ea typeface="Noto Sans CJK JP"/>
                 <a:cs typeface="Noto Sans"/>
               </a:rPr>
-              <a:t>昆虫と陸生節足動物と乗り物のカテゴリ</a:t>
+              <a:t>昆虫・陸生節足動物・乗り物の例</a:t>
             </a:r>
             <a:endParaRPr sz="2800" lang="ja-JP">
               <a:latin typeface="Noto Sans"/>
@@ -27313,7 +27313,7 @@
                 <a:ea typeface="Noto Sans CJK JP"/>
                 <a:cs typeface="Noto Sans"/>
               </a:rPr>
-              <a:t>電子機器と機械と衣類と生活用品のカテゴリ</a:t>
+              <a:t>電子機器・機械・衣類・生活用品の例</a:t>
             </a:r>
             <a:endParaRPr sz="2800" lang="ja-JP">
               <a:latin typeface="Noto Sans"/>
@@ -28850,7 +28850,7 @@
                 <a:ea typeface="Noto Sans CJK JP"/>
                 <a:cs typeface="Noto Sans"/>
               </a:rPr>
-              <a:t>建物と構造物と食品と農作物のカテゴリ</a:t>
+              <a:t>建物・構造物・食品・農作物の例</a:t>
             </a:r>
             <a:endParaRPr sz="2800" lang="ja-JP">
               <a:latin typeface="Noto Sans"/>
@@ -31609,7 +31609,7 @@
                 <a:ea typeface="Noto Sans CJK JP"/>
                 <a:cs typeface="Noto Sans"/>
               </a:rPr>
-              <a:t>この資料で扱うImageNet-1kの課題は画像分類であり、1枚の画像から1,000候補のカテゴリを予測する。</a:t>
+              <a:t>この資料で扱うImageNet-1kの課題は画像分類であり、1枚の画像に対して1,000候補の中からカテゴリを予測する。</a:t>
             </a:r>
           </a:p>
           <a:p>
@@ -31968,7 +31968,7 @@
                 <a:ea typeface="Noto Sans CJK JP"/>
                 <a:cs typeface="Noto Sans"/>
               </a:rPr>
-              <a:t>低い照度の画像も含む。</a:t>
+              <a:t>低照度の画像も含む。</a:t>
             </a:r>
             <a:endParaRPr sz="2100" lang="ja-JP">
               <a:latin typeface="Noto Sans"/>
@@ -35282,7 +35282,7 @@
                 <a:ea typeface="Noto Sans CJK JP"/>
                 <a:cs typeface="Noto Sans"/>
               </a:rPr>
-              <a:t>ImageNet-1kの学習用は約128万枚ある。そこで、画像サイズの実測には10クラス・13,394枚のImagenetteを使う [1, 2]。</a:t>
+              <a:t>ImageNet-1kの学習用は約128万枚ある。そこで、画像サイズの実測には10クラス・13,394枚のImagenetteを使う [1]。</a:t>
             </a:r>
             <a:endParaRPr sz="2400" lang="ja-JP">
               <a:latin typeface="Noto Sans"/>
@@ -37065,7 +37065,7 @@
         </p:nvSpPr>
         <p:spPr>
           <a:xfrm>
-            <a:off x="594360" y="4271256"/>
+            <a:off x="594360" y="4169656"/>
             <a:ext cx="7955279" cy="349885"/>
           </a:xfrm>
           <a:prstGeom prst="rect">
@@ -37105,7 +37105,7 @@
                 <a:ea typeface="Noto Sans CJK JP"/>
                 <a:cs typeface="Noto Sans"/>
               </a:rPr>
-              <a:t>Imagenette 160 px版。各画像のフォルダ名でクラスと分割を数えた。</a:t>
+              <a:t>Imagenette 160 px版。フォルダ名からクラス別・分割別に集計。</a:t>
             </a:r>
             <a:endParaRPr sz="1600" lang="ja-JP">
               <a:latin typeface="Noto Sans"/>
@@ -38838,7 +38838,7 @@
         </p:nvSpPr>
         <p:spPr>
           <a:xfrm>
-            <a:off x="594360" y="4271256"/>
+            <a:off x="594360" y="4169656"/>
             <a:ext cx="7955279" cy="349885"/>
           </a:xfrm>
           <a:prstGeom prst="rect">
@@ -38878,7 +38878,7 @@
                 <a:ea typeface="Noto Sans CJK JP"/>
                 <a:cs typeface="Noto Sans"/>
               </a:rPr>
-              <a:t>Imagenette 160 px版。各画像のフォルダ名でクラスと分割を数えた。</a:t>
+              <a:t>Imagenette 160 px版。フォルダ名からクラス別・分割別に集計。</a:t>
             </a:r>
             <a:endParaRPr sz="1600" lang="ja-JP">
               <a:latin typeface="Noto Sans"/>
@@ -45298,7 +45298,7 @@
                 <a:ea typeface="Noto Sans CJK JP"/>
                 <a:cs typeface="Noto Sans"/>
               </a:rPr>
-              <a:t>そこで顔を注釈し、顔をぼかした、ILSVRC大会の1,000クラス分類用データを検討した。</a:t>
+              <a:t>そこで顔を注釈し、顔をぼかしたILSVRC大会の1,000クラス分類用データを検討した。</a:t>
             </a:r>
             <a:endParaRPr sz="2200" lang="ja-JP">
               <a:latin typeface="Noto Sans"/>

</xml_diff>

<commit_message>
Use left-aligned explanatory prose in imagenet
</commit_message>
<xml_diff>
--- a/slides/datasets-in-10-minutes-imagenet.pptx
+++ b/slides/datasets-in-10-minutes-imagenet.pptx
@@ -35132,7 +35132,7 @@
         </p:nvSpPr>
         <p:spPr>
           <a:xfrm>
-            <a:off x="468172" y="1306789"/>
+            <a:off x="468172" y="650240"/>
             <a:ext cx="8206740" cy="594360"/>
           </a:xfrm>
         </p:spPr>
@@ -35140,7 +35140,7 @@
           <a:bodyPr wrap="square" lIns="0" rIns="0" tIns="0" bIns="0" anchor="t"/>
           <a:lstStyle/>
           <a:p>
-            <a:pPr algn="ctr" marL="0" indent="0">
+            <a:pPr algn="l" marL="0" indent="0">
               <a:lnSpc>
                 <a:spcPct val="100000"/>
               </a:lnSpc>
@@ -35242,8 +35242,8 @@
         </p:nvSpPr>
         <p:spPr>
           <a:xfrm>
-            <a:off x="594360" y="2221189"/>
-            <a:ext cx="7955279" cy="1737360"/>
+            <a:off x="594360" y="1508760"/>
+            <a:ext cx="7955279" cy="2794000"/>
           </a:xfrm>
           <a:prstGeom prst="rect">
             <a:avLst/>
@@ -35256,7 +35256,7 @@
           </a:bodyPr>
           <a:lstStyle/>
           <a:p>
-            <a:pPr algn="ctr" lvl="0" marL="0" indent="0">
+            <a:pPr algn="l" lvl="0" marL="0" indent="0">
               <a:lnSpc>
                 <a:spcPct val="100000"/>
               </a:lnSpc>
@@ -35282,7 +35282,7 @@
                 <a:ea typeface="Noto Sans CJK JP"/>
                 <a:cs typeface="Noto Sans"/>
               </a:rPr>
-              <a:t>ImageNet-1kの学習用は約128万枚ある。そこで、画像サイズの実測には10クラス・13,394枚のImagenetteを使う [1]。</a:t>
+              <a:t>ImageNet-1kの学習用画像は約128万枚あるため、画像サイズの実測には10クラス・13,394枚のImagenetteを使う [1]。</a:t>
             </a:r>
             <a:endParaRPr sz="2400" lang="ja-JP">
               <a:latin typeface="Noto Sans"/>
@@ -35291,7 +35291,7 @@
             </a:endParaRPr>
           </a:p>
           <a:p>
-            <a:pPr algn="ctr" marL="0" indent="0">
+            <a:pPr algn="l" marL="0" indent="0">
               <a:lnSpc>
                 <a:spcPct val="100000"/>
               </a:lnSpc>
@@ -35312,11 +35312,11 @@
                 <a:ea typeface="Noto Sans CJK JP"/>
                 <a:cs typeface="Noto Sans"/>
               </a:rPr>
-              <a:t>分析には、短辺160 pxへリサイズしたImagenetteの画像を使用する。</a:t>
-            </a:r>
-          </a:p>
-          <a:p>
-            <a:pPr algn="ctr" marL="0" indent="0">
+              <a:t>分析対象は、短辺を160 pxにリサイズした画像である。</a:t>
+            </a:r>
+          </a:p>
+          <a:p>
+            <a:pPr algn="l" marL="0" indent="0">
               <a:lnSpc>
                 <a:spcPct val="100000"/>
               </a:lnSpc>
@@ -35337,7 +35337,7 @@
                 <a:ea typeface="Noto Sans CJK JP"/>
                 <a:cs typeface="Noto Sans"/>
               </a:rPr>
-              <a:t>学習用9,469枚、検証用3,925枚。分割はImagenette独自のものである。</a:t>
+              <a:t>内訳は学習用9,469枚、検証用3,925枚で、Imagenette独自の分割を用いる。</a:t>
             </a:r>
           </a:p>
         </p:txBody>

</xml_diff>

<commit_message>
slides(imagenet): refine Japanese wording and pair translations
</commit_message>
<xml_diff>
--- a/slides/datasets-in-10-minutes-imagenet.pptx
+++ b/slides/datasets-in-10-minutes-imagenet.pptx
@@ -8520,7 +8520,7 @@
                 <a:ea typeface="Noto Sans CJK JP"/>
                 <a:cs typeface="Noto Sans"/>
               </a:rPr>
-              <a:t>これに対し、2009年のImageNet原著は約320万枚・5,247カテゴリを報告した。</a:t>
+              <a:t>これに対し、2009年には約320万枚・5,247カテゴリが報告された。</a:t>
             </a:r>
           </a:p>
           <a:p>
@@ -16439,7 +16439,7 @@
                 <a:ea typeface="Noto Sans CJK JP"/>
                 <a:cs typeface="Noto Sans"/>
               </a:rPr>
-              <a:t>2016年のResNet原著の評価結果</a:t>
+              <a:t>2016年のResNetの評価結果</a:t>
             </a:r>
             <a:endParaRPr sz="2800" lang="ja-JP">
               <a:latin typeface="Noto Sans"/>
@@ -22372,7 +22372,7 @@
                 <a:ea typeface="Noto Sans CJK JP"/>
                 <a:cs typeface="Noto Sans"/>
               </a:rPr>
-              <a:t>原著は2009年のCVPRで発表された [1]。</a:t>
+              <a:t>ImageNetは2009年のCVPRで発表された [1]。</a:t>
             </a:r>
             <a:endParaRPr sz="2300" lang="ja-JP">
               <a:latin typeface="Noto Sans"/>
@@ -22446,7 +22446,7 @@
                 <a:ea typeface="Noto Sans CJK JP"/>
                 <a:cs typeface="Noto Sans"/>
               </a:rPr>
-              <a:t>発表当時の所属はPrinceton大学だった。原著は2019年にPAMI Longuet-Higgins Prizeを受賞した [2]。</a:t>
+              <a:t>当時の所属はPrinceton大学だった。論文は2019年にPAMI Longuet-Higgins Prizeを受賞した [2]。</a:t>
             </a:r>
           </a:p>
         </p:txBody>
@@ -48071,7 +48071,7 @@
                 <a:ea typeface="Noto Sans CJK JP"/>
                 <a:cs typeface="Noto Sans"/>
               </a:rPr>
-              <a:t>ImageNetの原著論文。WordNet階層に沿う画像収集と人手による注釈を報告する。</a:t>
+              <a:t>WordNet階層に沿う画像収集と人手による注釈を報告する。</a:t>
             </a:r>
           </a:p>
         </p:txBody>
@@ -48575,7 +48575,7 @@
                 <a:ea typeface="Noto Sans CJK JP"/>
                 <a:cs typeface="Noto Sans"/>
               </a:rPr>
-              <a:t>ResNetの原著論文。残差接続による深いネットワークの学習とImageNet評価を示す。</a:t>
+              <a:t>残差接続による深いネットワークの学習とImageNet評価を示す。</a:t>
             </a:r>
           </a:p>
         </p:txBody>
@@ -49583,7 +49583,7 @@
                 <a:ea typeface="Noto Sans CJK JP"/>
                 <a:cs typeface="Noto Sans"/>
               </a:rPr>
-              <a:t>ImageNetV2の原著論文。新たに収集した画像で既存分類器の汎化性能を検証する。</a:t>
+              <a:t>新たに収集した画像で既存分類器の汎化性能を検証する。</a:t>
             </a:r>
           </a:p>
         </p:txBody>

</xml_diff>

<commit_message>
Improve imagenet answer visibility and citation wording
</commit_message>
<xml_diff>
--- a/slides/datasets-in-10-minutes-imagenet.pptx
+++ b/slides/datasets-in-10-minutes-imagenet.pptx
@@ -7509,9 +7509,9 @@
               </a:defRPr>
             </a:pPr>
             <a:r>
-              <a:rPr sz="2300" lang="ja-JP">
-                <a:solidFill>
-                  <a:srgbClr val="B13731"/>
+              <a:rPr sz="2300" lang="ja-JP" b="1">
+                <a:solidFill>
+                  <a:schemeClr val="accent1"/>
                 </a:solidFill>
                 <a:latin typeface="Noto Sans"/>
                 <a:ea typeface="Noto Sans CJK JP"/>
@@ -39695,9 +39695,9 @@
               </a:defRPr>
             </a:pPr>
             <a:r>
-              <a:rPr sz="2300" lang="ja-JP">
-                <a:solidFill>
-                  <a:srgbClr val="B13731"/>
+              <a:rPr sz="2300" lang="ja-JP" b="1">
+                <a:solidFill>
+                  <a:schemeClr val="accent1"/>
                 </a:solidFill>
                 <a:latin typeface="Noto Sans"/>
                 <a:ea typeface="Noto Sans CJK JP"/>
@@ -40198,9 +40198,9 @@
               </a:defRPr>
             </a:pPr>
             <a:r>
-              <a:rPr sz="2300" lang="ja-JP">
-                <a:solidFill>
-                  <a:srgbClr val="B13731"/>
+              <a:rPr sz="2300" lang="ja-JP" b="1">
+                <a:solidFill>
+                  <a:schemeClr val="accent1"/>
                 </a:solidFill>
                 <a:latin typeface="Noto Sans"/>
                 <a:ea typeface="Noto Sans CJK JP"/>
@@ -47543,9 +47543,9 @@
               </a:defRPr>
             </a:pPr>
             <a:r>
-              <a:rPr sz="2300" lang="ja-JP">
-                <a:solidFill>
-                  <a:srgbClr val="B13731"/>
+              <a:rPr sz="2300" lang="ja-JP" b="1">
+                <a:solidFill>
+                  <a:schemeClr val="accent1"/>
                 </a:solidFill>
                 <a:latin typeface="Noto Sans"/>
                 <a:ea typeface="Noto Sans CJK JP"/>

</xml_diff>